<commit_message>
docs: revise standalone arch views to confirmed decisions
Keep architecture as a separate PPT (not merged into main deck).
Independent preview service, direct publish with cloud-space backup,
single-file phase-1, WebView-only client; document AK/SK vs signed
URL guidance and omit streaming B/C from the main architecture.

Co-authored-by: Lizzy67 <Lizzy67@users.noreply.github.com>
</commit_message>
<xml_diff>
--- a/docs/agent_html_arch_views.pptx
+++ b/docs/agent_html_arch_views.pptx
@@ -7,6 +7,8 @@
   <p:sldIdLst>
     <p:sldId id="256" r:id="rId7"/>
     <p:sldId id="257" r:id="rId8"/>
+    <p:sldId id="258" r:id="rId9"/>
+    <p:sldId id="259" r:id="rId10"/>
   </p:sldIdLst>
   <p:sldSz cx="12191695" cy="6858000" type="screen4x3"/>
   <p:notesSz cx="6858000" cy="9144000"/>
@@ -3247,7 +3249,7 @@
                 </a:solidFill>
                 <a:latin typeface="Calibri"/>
               </a:rPr>
-              <a:t>逻辑架构图（草稿 · 请审）</a:t>
+              <a:t>架构视图（独立稿）</a:t>
             </a:r>
           </a:p>
           <a:p>
@@ -3258,7 +3260,7 @@
                 </a:solidFill>
                 <a:latin typeface="Calibri"/>
               </a:rPr>
-              <a:t>主路径=方案4；云空间=源文件仓；预览服务=可渲染 URL 入口</a:t>
+              <a:t>不并入主 PPT · 已按评审口径收敛：独立预览服务 / 直发预览 / 单文件 / WebView</a:t>
             </a:r>
           </a:p>
         </p:txBody>
@@ -3271,89 +3273,8 @@
         </p:nvSpPr>
         <p:spPr>
           <a:xfrm>
-            <a:off x="274320" y="960120"/>
-            <a:ext cx="11612880" cy="1417320"/>
-          </a:xfrm>
-          <a:prstGeom prst="roundRect">
-            <a:avLst>
-              <a:gd name="adj" fmla="val 3000"/>
-            </a:avLst>
-          </a:prstGeom>
-          <a:solidFill>
-            <a:srgbClr val="EFF6FF"/>
-          </a:solidFill>
-          <a:ln w="15875">
-            <a:solidFill>
-              <a:srgbClr val="CBD5E1"/>
-            </a:solidFill>
-          </a:ln>
-        </p:spPr>
-        <p:style>
-          <a:lnRef idx="1">
-            <a:schemeClr val="accent1"/>
-          </a:lnRef>
-          <a:fillRef idx="3">
-            <a:schemeClr val="accent1"/>
-          </a:fillRef>
-          <a:effectRef idx="2">
-            <a:schemeClr val="accent1"/>
-          </a:effectRef>
-          <a:fontRef idx="minor">
-            <a:schemeClr val="lt1"/>
-          </a:fontRef>
-        </p:style>
-        <p:txBody>
-          <a:bodyPr rtlCol="0" anchor="ctr"/>
-          <a:lstStyle/>
-          <a:p>
-            <a:pPr algn="ctr"/>
-          </a:p>
-        </p:txBody>
-      </p:sp>
-      <p:sp>
-        <p:nvSpPr>
-          <p:cNvPr id="7" name="TextBox 6"/>
-          <p:cNvSpPr txBox="1"/>
-          <p:nvPr/>
-        </p:nvSpPr>
-        <p:spPr>
-          <a:xfrm>
-            <a:off x="384048" y="1033272"/>
-            <a:ext cx="11430000" cy="274320"/>
-          </a:xfrm>
-          <a:prstGeom prst="rect">
-            <a:avLst/>
-          </a:prstGeom>
-          <a:noFill/>
-        </p:spPr>
-        <p:txBody>
-          <a:bodyPr wrap="square">
-            <a:spAutoFit/>
-          </a:bodyPr>
-          <a:lstStyle/>
-          <a:p>
-            <a:r>
-              <a:rPr sz="1100" b="1">
-                <a:solidFill>
-                  <a:srgbClr val="64748B"/>
-                </a:solidFill>
-                <a:latin typeface="Calibri"/>
-              </a:rPr>
-              <a:t>① 端侧</a:t>
-            </a:r>
-          </a:p>
-        </p:txBody>
-      </p:sp>
-      <p:sp>
-        <p:nvSpPr>
-          <p:cNvPr id="8" name="Rounded Rectangle 7"/>
-          <p:cNvSpPr/>
-          <p:nvPr/>
-        </p:nvSpPr>
-        <p:spPr>
-          <a:xfrm>
-            <a:off x="457200" y="1280160"/>
-            <a:ext cx="3657600" cy="914400"/>
+            <a:off x="365760" y="1188720"/>
+            <a:ext cx="3703320" cy="2194560"/>
           </a:xfrm>
           <a:prstGeom prst="roundRect">
             <a:avLst>
@@ -3361,104 +3282,7 @@
             </a:avLst>
           </a:prstGeom>
           <a:solidFill>
-            <a:srgbClr val="FFFFFF"/>
-          </a:solidFill>
-          <a:ln w="15875">
-            <a:solidFill>
-              <a:srgbClr val="2563EB"/>
-            </a:solidFill>
-          </a:ln>
-        </p:spPr>
-        <p:style>
-          <a:lnRef idx="1">
-            <a:schemeClr val="accent1"/>
-          </a:lnRef>
-          <a:fillRef idx="3">
-            <a:schemeClr val="accent1"/>
-          </a:fillRef>
-          <a:effectRef idx="2">
-            <a:schemeClr val="accent1"/>
-          </a:effectRef>
-          <a:fontRef idx="minor">
-            <a:schemeClr val="lt1"/>
-          </a:fontRef>
-        </p:style>
-        <p:txBody>
-          <a:bodyPr rtlCol="0" anchor="ctr"/>
-          <a:lstStyle/>
-          <a:p>
-            <a:pPr algn="ctr"/>
-          </a:p>
-        </p:txBody>
-      </p:sp>
-      <p:sp>
-        <p:nvSpPr>
-          <p:cNvPr id="9" name="TextBox 8"/>
-          <p:cNvSpPr txBox="1"/>
-          <p:nvPr/>
-        </p:nvSpPr>
-        <p:spPr>
-          <a:xfrm>
-            <a:off x="566928" y="1371600"/>
-            <a:ext cx="3456432" cy="768096"/>
-          </a:xfrm>
-          <a:prstGeom prst="rect">
-            <a:avLst/>
-          </a:prstGeom>
-          <a:noFill/>
-        </p:spPr>
-        <p:txBody>
-          <a:bodyPr wrap="square">
-            <a:spAutoFit/>
-          </a:bodyPr>
-          <a:lstStyle/>
-          <a:p>
-            <a:r>
-              <a:rPr sz="1200" b="1">
-                <a:solidFill>
-                  <a:srgbClr val="2563EB"/>
-                </a:solidFill>
-                <a:latin typeface="Calibri"/>
-              </a:rPr>
-              <a:t>对话 UI</a:t>
-            </a:r>
-          </a:p>
-          <a:p>
-            <a:pPr>
-              <a:spcBef>
-                <a:spcPts val="200"/>
-              </a:spcBef>
-            </a:pPr>
-            <a:r>
-              <a:rPr sz="1000" b="0">
-                <a:solidFill>
-                  <a:srgbClr val="334155"/>
-                </a:solidFill>
-                <a:latin typeface="Calibri"/>
-              </a:rPr>
-              <a:t>触发任务 / 展示预览卡片</a:t>
-            </a:r>
-          </a:p>
-        </p:txBody>
-      </p:sp>
-      <p:sp>
-        <p:nvSpPr>
-          <p:cNvPr id="10" name="Rounded Rectangle 9"/>
-          <p:cNvSpPr/>
-          <p:nvPr/>
-        </p:nvSpPr>
-        <p:spPr>
-          <a:xfrm>
-            <a:off x="4297680" y="1280160"/>
-            <a:ext cx="3749039" cy="914400"/>
-          </a:xfrm>
-          <a:prstGeom prst="roundRect">
-            <a:avLst>
-              <a:gd name="adj" fmla="val 8000"/>
-            </a:avLst>
-          </a:prstGeom>
-          <a:solidFill>
-            <a:srgbClr val="FFFFFF"/>
+            <a:srgbClr val="F0FDFA"/>
           </a:solidFill>
           <a:ln w="15875">
             <a:solidFill>
@@ -3490,14 +3314,208 @@
       </p:sp>
       <p:sp>
         <p:nvSpPr>
+          <p:cNvPr id="7" name="TextBox 6"/>
+          <p:cNvSpPr txBox="1"/>
+          <p:nvPr/>
+        </p:nvSpPr>
+        <p:spPr>
+          <a:xfrm>
+            <a:off x="475488" y="1280160"/>
+            <a:ext cx="3502152" cy="2048256"/>
+          </a:xfrm>
+          <a:prstGeom prst="rect">
+            <a:avLst/>
+          </a:prstGeom>
+          <a:noFill/>
+        </p:spPr>
+        <p:txBody>
+          <a:bodyPr wrap="square">
+            <a:spAutoFit/>
+          </a:bodyPr>
+          <a:lstStyle/>
+          <a:p>
+            <a:r>
+              <a:rPr sz="1200" b="1">
+                <a:solidFill>
+                  <a:srgbClr val="0F766E"/>
+                </a:solidFill>
+                <a:latin typeface="Calibri"/>
+              </a:rPr>
+              <a:t>预览服务</a:t>
+            </a:r>
+          </a:p>
+          <a:p>
+            <a:pPr>
+              <a:spcBef>
+                <a:spcPts val="300"/>
+              </a:spcBef>
+            </a:pPr>
+            <a:r>
+              <a:rPr sz="1100" b="0">
+                <a:solidFill>
+                  <a:srgbClr val="334155"/>
+                </a:solidFill>
+                <a:latin typeface="Calibri"/>
+              </a:rPr>
+              <a:t>独立新服务（Preview Web Service）</a:t>
+            </a:r>
+          </a:p>
+        </p:txBody>
+      </p:sp>
+      <p:sp>
+        <p:nvSpPr>
+          <p:cNvPr id="8" name="Rounded Rectangle 7"/>
+          <p:cNvSpPr/>
+          <p:nvPr/>
+        </p:nvSpPr>
+        <p:spPr>
+          <a:xfrm>
+            <a:off x="4251960" y="1188720"/>
+            <a:ext cx="3703320" cy="2194560"/>
+          </a:xfrm>
+          <a:prstGeom prst="roundRect">
+            <a:avLst>
+              <a:gd name="adj" fmla="val 8000"/>
+            </a:avLst>
+          </a:prstGeom>
+          <a:solidFill>
+            <a:srgbClr val="F0FDFA"/>
+          </a:solidFill>
+          <a:ln w="15875">
+            <a:solidFill>
+              <a:srgbClr val="0D9488"/>
+            </a:solidFill>
+          </a:ln>
+        </p:spPr>
+        <p:style>
+          <a:lnRef idx="1">
+            <a:schemeClr val="accent1"/>
+          </a:lnRef>
+          <a:fillRef idx="3">
+            <a:schemeClr val="accent1"/>
+          </a:fillRef>
+          <a:effectRef idx="2">
+            <a:schemeClr val="accent1"/>
+          </a:effectRef>
+          <a:fontRef idx="minor">
+            <a:schemeClr val="lt1"/>
+          </a:fontRef>
+        </p:style>
+        <p:txBody>
+          <a:bodyPr rtlCol="0" anchor="ctr"/>
+          <a:lstStyle/>
+          <a:p>
+            <a:pPr algn="ctr"/>
+          </a:p>
+        </p:txBody>
+      </p:sp>
+      <p:sp>
+        <p:nvSpPr>
+          <p:cNvPr id="9" name="TextBox 8"/>
+          <p:cNvSpPr txBox="1"/>
+          <p:nvPr/>
+        </p:nvSpPr>
+        <p:spPr>
+          <a:xfrm>
+            <a:off x="4361688" y="1280160"/>
+            <a:ext cx="3502152" cy="2048256"/>
+          </a:xfrm>
+          <a:prstGeom prst="rect">
+            <a:avLst/>
+          </a:prstGeom>
+          <a:noFill/>
+        </p:spPr>
+        <p:txBody>
+          <a:bodyPr wrap="square">
+            <a:spAutoFit/>
+          </a:bodyPr>
+          <a:lstStyle/>
+          <a:p>
+            <a:r>
+              <a:rPr sz="1200" b="1">
+                <a:solidFill>
+                  <a:srgbClr val="0F766E"/>
+                </a:solidFill>
+                <a:latin typeface="Calibri"/>
+              </a:rPr>
+              <a:t>发布路径</a:t>
+            </a:r>
+          </a:p>
+          <a:p>
+            <a:pPr>
+              <a:spcBef>
+                <a:spcPts val="300"/>
+              </a:spcBef>
+            </a:pPr>
+            <a:r>
+              <a:rPr sz="1100" b="0">
+                <a:solidFill>
+                  <a:srgbClr val="334155"/>
+                </a:solidFill>
+                <a:latin typeface="Calibri"/>
+              </a:rPr>
+              <a:t>HTML 直发预览服务；云空间仅备份</a:t>
+            </a:r>
+          </a:p>
+        </p:txBody>
+      </p:sp>
+      <p:sp>
+        <p:nvSpPr>
+          <p:cNvPr id="10" name="Rounded Rectangle 9"/>
+          <p:cNvSpPr/>
+          <p:nvPr/>
+        </p:nvSpPr>
+        <p:spPr>
+          <a:xfrm>
+            <a:off x="8138160" y="1188720"/>
+            <a:ext cx="3703320" cy="2194560"/>
+          </a:xfrm>
+          <a:prstGeom prst="roundRect">
+            <a:avLst>
+              <a:gd name="adj" fmla="val 8000"/>
+            </a:avLst>
+          </a:prstGeom>
+          <a:solidFill>
+            <a:srgbClr val="F0FDFA"/>
+          </a:solidFill>
+          <a:ln w="15875">
+            <a:solidFill>
+              <a:srgbClr val="0D9488"/>
+            </a:solidFill>
+          </a:ln>
+        </p:spPr>
+        <p:style>
+          <a:lnRef idx="1">
+            <a:schemeClr val="accent1"/>
+          </a:lnRef>
+          <a:fillRef idx="3">
+            <a:schemeClr val="accent1"/>
+          </a:fillRef>
+          <a:effectRef idx="2">
+            <a:schemeClr val="accent1"/>
+          </a:effectRef>
+          <a:fontRef idx="minor">
+            <a:schemeClr val="lt1"/>
+          </a:fontRef>
+        </p:style>
+        <p:txBody>
+          <a:bodyPr rtlCol="0" anchor="ctr"/>
+          <a:lstStyle/>
+          <a:p>
+            <a:pPr algn="ctr"/>
+          </a:p>
+        </p:txBody>
+      </p:sp>
+      <p:sp>
+        <p:nvSpPr>
           <p:cNvPr id="11" name="TextBox 10"/>
           <p:cNvSpPr txBox="1"/>
           <p:nvPr/>
         </p:nvSpPr>
         <p:spPr>
           <a:xfrm>
-            <a:off x="4407408" y="1371600"/>
-            <a:ext cx="3547871" cy="768096"/>
+            <a:off x="8247888" y="1280160"/>
+            <a:ext cx="3502152" cy="2048256"/>
           </a:xfrm>
           <a:prstGeom prst="rect">
             <a:avLst/>
@@ -3517,39 +3535,23 @@
                 </a:solidFill>
                 <a:latin typeface="Calibri"/>
               </a:rPr>
-              <a:t>WebView / iframe ★</a:t>
+              <a:t>一期范围</a:t>
             </a:r>
           </a:p>
           <a:p>
             <a:pPr>
               <a:spcBef>
-                <a:spcPts val="200"/>
+                <a:spcPts val="300"/>
               </a:spcBef>
             </a:pPr>
             <a:r>
-              <a:rPr sz="1000" b="0">
+              <a:rPr sz="1100" b="0">
                 <a:solidFill>
                   <a:srgbClr val="334155"/>
                 </a:solidFill>
                 <a:latin typeface="Calibri"/>
               </a:rPr>
-              <a:t>直接打开 preview_url</a:t>
-            </a:r>
-          </a:p>
-          <a:p>
-            <a:pPr>
-              <a:spcBef>
-                <a:spcPts val="200"/>
-              </a:spcBef>
-            </a:pPr>
-            <a:r>
-              <a:rPr sz="1000" b="0">
-                <a:solidFill>
-                  <a:srgbClr val="334155"/>
-                </a:solidFill>
-                <a:latin typeface="Calibri"/>
-              </a:rPr>
-              <a:t>会话内渲染 HTML</a:t>
+              <a:t>只做单文件 HTML（CSS/JS 内联）</a:t>
             </a:r>
           </a:p>
         </p:txBody>
@@ -3562,8 +3564,105 @@
         </p:nvSpPr>
         <p:spPr>
           <a:xfrm>
-            <a:off x="8229600" y="1280160"/>
-            <a:ext cx="3383280" cy="914400"/>
+            <a:off x="365760" y="3657600"/>
+            <a:ext cx="3703320" cy="2194560"/>
+          </a:xfrm>
+          <a:prstGeom prst="roundRect">
+            <a:avLst>
+              <a:gd name="adj" fmla="val 8000"/>
+            </a:avLst>
+          </a:prstGeom>
+          <a:solidFill>
+            <a:srgbClr val="F0FDFA"/>
+          </a:solidFill>
+          <a:ln w="15875">
+            <a:solidFill>
+              <a:srgbClr val="0D9488"/>
+            </a:solidFill>
+          </a:ln>
+        </p:spPr>
+        <p:style>
+          <a:lnRef idx="1">
+            <a:schemeClr val="accent1"/>
+          </a:lnRef>
+          <a:fillRef idx="3">
+            <a:schemeClr val="accent1"/>
+          </a:fillRef>
+          <a:effectRef idx="2">
+            <a:schemeClr val="accent1"/>
+          </a:effectRef>
+          <a:fontRef idx="minor">
+            <a:schemeClr val="lt1"/>
+          </a:fontRef>
+        </p:style>
+        <p:txBody>
+          <a:bodyPr rtlCol="0" anchor="ctr"/>
+          <a:lstStyle/>
+          <a:p>
+            <a:pPr algn="ctr"/>
+          </a:p>
+        </p:txBody>
+      </p:sp>
+      <p:sp>
+        <p:nvSpPr>
+          <p:cNvPr id="13" name="TextBox 12"/>
+          <p:cNvSpPr txBox="1"/>
+          <p:nvPr/>
+        </p:nvSpPr>
+        <p:spPr>
+          <a:xfrm>
+            <a:off x="475488" y="3749040"/>
+            <a:ext cx="3502152" cy="2048256"/>
+          </a:xfrm>
+          <a:prstGeom prst="rect">
+            <a:avLst/>
+          </a:prstGeom>
+          <a:noFill/>
+        </p:spPr>
+        <p:txBody>
+          <a:bodyPr wrap="square">
+            <a:spAutoFit/>
+          </a:bodyPr>
+          <a:lstStyle/>
+          <a:p>
+            <a:r>
+              <a:rPr sz="1200" b="1">
+                <a:solidFill>
+                  <a:srgbClr val="0F766E"/>
+                </a:solidFill>
+                <a:latin typeface="Calibri"/>
+              </a:rPr>
+              <a:t>端侧呈现</a:t>
+            </a:r>
+          </a:p>
+          <a:p>
+            <a:pPr>
+              <a:spcBef>
+                <a:spcPts val="300"/>
+              </a:spcBef>
+            </a:pPr>
+            <a:r>
+              <a:rPr sz="1100" b="0">
+                <a:solidFill>
+                  <a:srgbClr val="334155"/>
+                </a:solidFill>
+                <a:latin typeface="Calibri"/>
+              </a:rPr>
+              <a:t>WebView 组件直接打开 preview_url</a:t>
+            </a:r>
+          </a:p>
+        </p:txBody>
+      </p:sp>
+      <p:sp>
+        <p:nvSpPr>
+          <p:cNvPr id="14" name="Rounded Rectangle 13"/>
+          <p:cNvSpPr/>
+          <p:nvPr/>
+        </p:nvSpPr>
+        <p:spPr>
+          <a:xfrm>
+            <a:off x="4251960" y="3657600"/>
+            <a:ext cx="3703320" cy="2194560"/>
           </a:xfrm>
           <a:prstGeom prst="roundRect">
             <a:avLst>
@@ -3603,14 +3702,14 @@
       </p:sp>
       <p:sp>
         <p:nvSpPr>
-          <p:cNvPr id="13" name="TextBox 12"/>
+          <p:cNvPr id="15" name="TextBox 14"/>
           <p:cNvSpPr txBox="1"/>
           <p:nvPr/>
         </p:nvSpPr>
         <p:spPr>
           <a:xfrm>
-            <a:off x="8339328" y="1371600"/>
-            <a:ext cx="3182112" cy="768096"/>
+            <a:off x="4361688" y="3749040"/>
+            <a:ext cx="3502152" cy="2048256"/>
           </a:xfrm>
           <a:prstGeom prst="rect">
             <a:avLst/>
@@ -3630,65 +3729,49 @@
                 </a:solidFill>
                 <a:latin typeface="Calibri"/>
               </a:rPr>
-              <a:t>可选兜底 A</a:t>
+              <a:t>鉴权（待定）</a:t>
             </a:r>
           </a:p>
           <a:p>
             <a:pPr>
               <a:spcBef>
-                <a:spcPts val="200"/>
+                <a:spcPts val="300"/>
               </a:spcBef>
             </a:pPr>
             <a:r>
-              <a:rPr sz="1000" b="0">
+              <a:rPr sz="1100" b="0">
                 <a:solidFill>
                   <a:srgbClr val="334155"/>
                 </a:solidFill>
                 <a:latin typeface="Calibri"/>
               </a:rPr>
-              <a:t>REST 下载 → srcdoc</a:t>
-            </a:r>
-          </a:p>
-          <a:p>
-            <a:pPr>
-              <a:spcBef>
-                <a:spcPts val="200"/>
-              </a:spcBef>
-            </a:pPr>
-            <a:r>
-              <a:rPr sz="1000" b="0">
-                <a:solidFill>
-                  <a:srgbClr val="334155"/>
-                </a:solidFill>
-                <a:latin typeface="Calibri"/>
-              </a:rPr>
-              <a:t>预览服务不可用时</a:t>
-            </a:r>
-          </a:p>
-        </p:txBody>
-      </p:sp>
-      <p:sp>
-        <p:nvSpPr>
-          <p:cNvPr id="14" name="Rounded Rectangle 13"/>
+              <a:t>优先评估复用端云 AK/SK；WebView 打开链建议另议短签</a:t>
+            </a:r>
+          </a:p>
+        </p:txBody>
+      </p:sp>
+      <p:sp>
+        <p:nvSpPr>
+          <p:cNvPr id="16" name="Rounded Rectangle 15"/>
           <p:cNvSpPr/>
           <p:nvPr/>
         </p:nvSpPr>
         <p:spPr>
           <a:xfrm>
-            <a:off x="274320" y="2514600"/>
-            <a:ext cx="11612880" cy="1554480"/>
+            <a:off x="8138160" y="3657600"/>
+            <a:ext cx="3703320" cy="2194560"/>
           </a:xfrm>
           <a:prstGeom prst="roundRect">
             <a:avLst>
-              <a:gd name="adj" fmla="val 3000"/>
+              <a:gd name="adj" fmla="val 8000"/>
             </a:avLst>
           </a:prstGeom>
           <a:solidFill>
-            <a:srgbClr val="F0FDFA"/>
+            <a:srgbClr val="FFFBEB"/>
           </a:solidFill>
           <a:ln w="15875">
             <a:solidFill>
-              <a:srgbClr val="CBD5E1"/>
+              <a:srgbClr val="B45309"/>
             </a:solidFill>
           </a:ln>
         </p:spPr>
@@ -3716,14 +3799,14 @@
       </p:sp>
       <p:sp>
         <p:nvSpPr>
-          <p:cNvPr id="15" name="TextBox 14"/>
+          <p:cNvPr id="17" name="TextBox 16"/>
           <p:cNvSpPr txBox="1"/>
           <p:nvPr/>
         </p:nvSpPr>
         <p:spPr>
           <a:xfrm>
-            <a:off x="384048" y="2587752"/>
-            <a:ext cx="11430000" cy="274320"/>
+            <a:off x="8247888" y="3749040"/>
+            <a:ext cx="3502152" cy="2048256"/>
           </a:xfrm>
           <a:prstGeom prst="rect">
             <a:avLst/>
@@ -3737,998 +3820,29 @@
           <a:lstStyle/>
           <a:p>
             <a:r>
-              <a:rPr sz="1100" b="1">
-                <a:solidFill>
-                  <a:srgbClr val="64748B"/>
-                </a:solidFill>
-                <a:latin typeface="Calibri"/>
-              </a:rPr>
-              <a:t>② Agent 运行时</a:t>
-            </a:r>
-          </a:p>
-        </p:txBody>
-      </p:sp>
-      <p:sp>
-        <p:nvSpPr>
-          <p:cNvPr id="16" name="Rounded Rectangle 15"/>
-          <p:cNvSpPr/>
-          <p:nvPr/>
-        </p:nvSpPr>
-        <p:spPr>
-          <a:xfrm>
-            <a:off x="457200" y="2880360"/>
-            <a:ext cx="2697480" cy="1005840"/>
-          </a:xfrm>
-          <a:prstGeom prst="roundRect">
-            <a:avLst>
-              <a:gd name="adj" fmla="val 8000"/>
-            </a:avLst>
-          </a:prstGeom>
-          <a:solidFill>
-            <a:srgbClr val="FFFFFF"/>
-          </a:solidFill>
-          <a:ln w="15875">
-            <a:solidFill>
-              <a:srgbClr val="0D9488"/>
-            </a:solidFill>
-          </a:ln>
-        </p:spPr>
-        <p:style>
-          <a:lnRef idx="1">
-            <a:schemeClr val="accent1"/>
-          </a:lnRef>
-          <a:fillRef idx="3">
-            <a:schemeClr val="accent1"/>
-          </a:fillRef>
-          <a:effectRef idx="2">
-            <a:schemeClr val="accent1"/>
-          </a:effectRef>
-          <a:fontRef idx="minor">
-            <a:schemeClr val="lt1"/>
-          </a:fontRef>
-        </p:style>
-        <p:txBody>
-          <a:bodyPr rtlCol="0" anchor="ctr"/>
-          <a:lstStyle/>
-          <a:p>
-            <a:pPr algn="ctr"/>
-          </a:p>
-        </p:txBody>
-      </p:sp>
-      <p:sp>
-        <p:nvSpPr>
-          <p:cNvPr id="17" name="TextBox 16"/>
-          <p:cNvSpPr txBox="1"/>
-          <p:nvPr/>
-        </p:nvSpPr>
-        <p:spPr>
-          <a:xfrm>
-            <a:off x="566928" y="2971800"/>
-            <a:ext cx="2496312" cy="859536"/>
-          </a:xfrm>
-          <a:prstGeom prst="rect">
-            <a:avLst/>
-          </a:prstGeom>
-          <a:noFill/>
-        </p:spPr>
-        <p:txBody>
-          <a:bodyPr wrap="square">
-            <a:spAutoFit/>
-          </a:bodyPr>
-          <a:lstStyle/>
-          <a:p>
-            <a:r>
               <a:rPr sz="1200" b="1">
                 <a:solidFill>
-                  <a:srgbClr val="0F766E"/>
-                </a:solidFill>
-                <a:latin typeface="Calibri"/>
-              </a:rPr>
-              <a:t>编排 / Session</a:t>
+                  <a:srgbClr val="B45309"/>
+                </a:solidFill>
+                <a:latin typeface="Calibri"/>
+              </a:rPr>
+              <a:t>不进本图</a:t>
             </a:r>
           </a:p>
           <a:p>
             <a:pPr>
               <a:spcBef>
-                <a:spcPts val="200"/>
+                <a:spcPts val="300"/>
               </a:spcBef>
             </a:pPr>
             <a:r>
-              <a:rPr sz="1000" b="0">
+              <a:rPr sz="1100" b="0">
                 <a:solidFill>
                   <a:srgbClr val="334155"/>
                 </a:solidFill>
                 <a:latin typeface="Calibri"/>
               </a:rPr>
-              <a:t>对话上下文</a:t>
-            </a:r>
-          </a:p>
-          <a:p>
-            <a:pPr>
-              <a:spcBef>
-                <a:spcPts val="200"/>
-              </a:spcBef>
-            </a:pPr>
-            <a:r>
-              <a:rPr sz="1000" b="0">
-                <a:solidFill>
-                  <a:srgbClr val="334155"/>
-                </a:solidFill>
-                <a:latin typeface="Calibri"/>
-              </a:rPr>
-              <a:t>工具调用编排</a:t>
-            </a:r>
-          </a:p>
-        </p:txBody>
-      </p:sp>
-      <p:sp>
-        <p:nvSpPr>
-          <p:cNvPr id="18" name="Rounded Rectangle 17"/>
-          <p:cNvSpPr/>
-          <p:nvPr/>
-        </p:nvSpPr>
-        <p:spPr>
-          <a:xfrm>
-            <a:off x="3291840" y="2880360"/>
-            <a:ext cx="2697480" cy="1005840"/>
-          </a:xfrm>
-          <a:prstGeom prst="roundRect">
-            <a:avLst>
-              <a:gd name="adj" fmla="val 8000"/>
-            </a:avLst>
-          </a:prstGeom>
-          <a:solidFill>
-            <a:srgbClr val="FFFFFF"/>
-          </a:solidFill>
-          <a:ln w="15875">
-            <a:solidFill>
-              <a:srgbClr val="0D9488"/>
-            </a:solidFill>
-          </a:ln>
-        </p:spPr>
-        <p:style>
-          <a:lnRef idx="1">
-            <a:schemeClr val="accent1"/>
-          </a:lnRef>
-          <a:fillRef idx="3">
-            <a:schemeClr val="accent1"/>
-          </a:fillRef>
-          <a:effectRef idx="2">
-            <a:schemeClr val="accent1"/>
-          </a:effectRef>
-          <a:fontRef idx="minor">
-            <a:schemeClr val="lt1"/>
-          </a:fontRef>
-        </p:style>
-        <p:txBody>
-          <a:bodyPr rtlCol="0" anchor="ctr"/>
-          <a:lstStyle/>
-          <a:p>
-            <a:pPr algn="ctr"/>
-          </a:p>
-        </p:txBody>
-      </p:sp>
-      <p:sp>
-        <p:nvSpPr>
-          <p:cNvPr id="19" name="TextBox 18"/>
-          <p:cNvSpPr txBox="1"/>
-          <p:nvPr/>
-        </p:nvSpPr>
-        <p:spPr>
-          <a:xfrm>
-            <a:off x="3401568" y="2971800"/>
-            <a:ext cx="2496312" cy="859536"/>
-          </a:xfrm>
-          <a:prstGeom prst="rect">
-            <a:avLst/>
-          </a:prstGeom>
-          <a:noFill/>
-        </p:spPr>
-        <p:txBody>
-          <a:bodyPr wrap="square">
-            <a:spAutoFit/>
-          </a:bodyPr>
-          <a:lstStyle/>
-          <a:p>
-            <a:r>
-              <a:rPr sz="1200" b="1">
-                <a:solidFill>
-                  <a:srgbClr val="0F766E"/>
-                </a:solidFill>
-                <a:latin typeface="Calibri"/>
-              </a:rPr>
-              <a:t>LLM</a:t>
-            </a:r>
-          </a:p>
-          <a:p>
-            <a:pPr>
-              <a:spcBef>
-                <a:spcPts val="200"/>
-              </a:spcBef>
-            </a:pPr>
-            <a:r>
-              <a:rPr sz="1000" b="0">
-                <a:solidFill>
-                  <a:srgbClr val="334155"/>
-                </a:solidFill>
-                <a:latin typeface="Calibri"/>
-              </a:rPr>
-              <a:t>生成图形化 HTML</a:t>
-            </a:r>
-          </a:p>
-          <a:p>
-            <a:pPr>
-              <a:spcBef>
-                <a:spcPts val="200"/>
-              </a:spcBef>
-            </a:pPr>
-            <a:r>
-              <a:rPr sz="1000" b="0">
-                <a:solidFill>
-                  <a:srgbClr val="334155"/>
-                </a:solidFill>
-                <a:latin typeface="Calibri"/>
-              </a:rPr>
-              <a:t>报告文案与结构</a:t>
-            </a:r>
-          </a:p>
-        </p:txBody>
-      </p:sp>
-      <p:sp>
-        <p:nvSpPr>
-          <p:cNvPr id="20" name="Rounded Rectangle 19"/>
-          <p:cNvSpPr/>
-          <p:nvPr/>
-        </p:nvSpPr>
-        <p:spPr>
-          <a:xfrm>
-            <a:off x="6126480" y="2880360"/>
-            <a:ext cx="2697480" cy="1005840"/>
-          </a:xfrm>
-          <a:prstGeom prst="roundRect">
-            <a:avLst>
-              <a:gd name="adj" fmla="val 8000"/>
-            </a:avLst>
-          </a:prstGeom>
-          <a:solidFill>
-            <a:srgbClr val="FFFFFF"/>
-          </a:solidFill>
-          <a:ln w="15875">
-            <a:solidFill>
-              <a:srgbClr val="0D9488"/>
-            </a:solidFill>
-          </a:ln>
-        </p:spPr>
-        <p:style>
-          <a:lnRef idx="1">
-            <a:schemeClr val="accent1"/>
-          </a:lnRef>
-          <a:fillRef idx="3">
-            <a:schemeClr val="accent1"/>
-          </a:fillRef>
-          <a:effectRef idx="2">
-            <a:schemeClr val="accent1"/>
-          </a:effectRef>
-          <a:fontRef idx="minor">
-            <a:schemeClr val="lt1"/>
-          </a:fontRef>
-        </p:style>
-        <p:txBody>
-          <a:bodyPr rtlCol="0" anchor="ctr"/>
-          <a:lstStyle/>
-          <a:p>
-            <a:pPr algn="ctr"/>
-          </a:p>
-        </p:txBody>
-      </p:sp>
-      <p:sp>
-        <p:nvSpPr>
-          <p:cNvPr id="21" name="TextBox 20"/>
-          <p:cNvSpPr txBox="1"/>
-          <p:nvPr/>
-        </p:nvSpPr>
-        <p:spPr>
-          <a:xfrm>
-            <a:off x="6236208" y="2971800"/>
-            <a:ext cx="2496312" cy="859536"/>
-          </a:xfrm>
-          <a:prstGeom prst="rect">
-            <a:avLst/>
-          </a:prstGeom>
-          <a:noFill/>
-        </p:spPr>
-        <p:txBody>
-          <a:bodyPr wrap="square">
-            <a:spAutoFit/>
-          </a:bodyPr>
-          <a:lstStyle/>
-          <a:p>
-            <a:r>
-              <a:rPr sz="1200" b="1">
-                <a:solidFill>
-                  <a:srgbClr val="0F766E"/>
-                </a:solidFill>
-                <a:latin typeface="Calibri"/>
-              </a:rPr>
-              <a:t>Skills</a:t>
-            </a:r>
-          </a:p>
-          <a:p>
-            <a:pPr>
-              <a:spcBef>
-                <a:spcPts val="200"/>
-              </a:spcBef>
-            </a:pPr>
-            <a:r>
-              <a:rPr sz="1000" b="0">
-                <a:solidFill>
-                  <a:srgbClr val="334155"/>
-                </a:solidFill>
-                <a:latin typeface="Calibri"/>
-              </a:rPr>
-              <a:t>运动健康数据</a:t>
-            </a:r>
-          </a:p>
-          <a:p>
-            <a:pPr>
-              <a:spcBef>
-                <a:spcPts val="200"/>
-              </a:spcBef>
-            </a:pPr>
-            <a:r>
-              <a:rPr sz="1000" b="0">
-                <a:solidFill>
-                  <a:srgbClr val="334155"/>
-                </a:solidFill>
-                <a:latin typeface="Calibri"/>
-              </a:rPr>
-              <a:t>其它业务取数</a:t>
-            </a:r>
-          </a:p>
-        </p:txBody>
-      </p:sp>
-      <p:sp>
-        <p:nvSpPr>
-          <p:cNvPr id="22" name="Rounded Rectangle 21"/>
-          <p:cNvSpPr/>
-          <p:nvPr/>
-        </p:nvSpPr>
-        <p:spPr>
-          <a:xfrm>
-            <a:off x="8961120" y="2880360"/>
-            <a:ext cx="2651760" cy="1005840"/>
-          </a:xfrm>
-          <a:prstGeom prst="roundRect">
-            <a:avLst>
-              <a:gd name="adj" fmla="val 8000"/>
-            </a:avLst>
-          </a:prstGeom>
-          <a:solidFill>
-            <a:srgbClr val="FFFFFF"/>
-          </a:solidFill>
-          <a:ln w="15875">
-            <a:solidFill>
-              <a:srgbClr val="0F766E"/>
-            </a:solidFill>
-          </a:ln>
-        </p:spPr>
-        <p:style>
-          <a:lnRef idx="1">
-            <a:schemeClr val="accent1"/>
-          </a:lnRef>
-          <a:fillRef idx="3">
-            <a:schemeClr val="accent1"/>
-          </a:fillRef>
-          <a:effectRef idx="2">
-            <a:schemeClr val="accent1"/>
-          </a:effectRef>
-          <a:fontRef idx="minor">
-            <a:schemeClr val="lt1"/>
-          </a:fontRef>
-        </p:style>
-        <p:txBody>
-          <a:bodyPr rtlCol="0" anchor="ctr"/>
-          <a:lstStyle/>
-          <a:p>
-            <a:pPr algn="ctr"/>
-          </a:p>
-        </p:txBody>
-      </p:sp>
-      <p:sp>
-        <p:nvSpPr>
-          <p:cNvPr id="23" name="TextBox 22"/>
-          <p:cNvSpPr txBox="1"/>
-          <p:nvPr/>
-        </p:nvSpPr>
-        <p:spPr>
-          <a:xfrm>
-            <a:off x="9070848" y="2971800"/>
-            <a:ext cx="2450592" cy="859536"/>
-          </a:xfrm>
-          <a:prstGeom prst="rect">
-            <a:avLst/>
-          </a:prstGeom>
-          <a:noFill/>
-        </p:spPr>
-        <p:txBody>
-          <a:bodyPr wrap="square">
-            <a:spAutoFit/>
-          </a:bodyPr>
-          <a:lstStyle/>
-          <a:p>
-            <a:r>
-              <a:rPr sz="1200" b="1">
-                <a:solidFill>
-                  <a:srgbClr val="0F766E"/>
-                </a:solidFill>
-                <a:latin typeface="Calibri"/>
-              </a:rPr>
-              <a:t>Tools</a:t>
-            </a:r>
-          </a:p>
-          <a:p>
-            <a:pPr>
-              <a:spcBef>
-                <a:spcPts val="200"/>
-              </a:spcBef>
-            </a:pPr>
-            <a:r>
-              <a:rPr sz="1000" b="0">
-                <a:solidFill>
-                  <a:srgbClr val="334155"/>
-                </a:solidFill>
-                <a:latin typeface="Calibri"/>
-              </a:rPr>
-              <a:t>write</a:t>
-            </a:r>
-          </a:p>
-          <a:p>
-            <a:pPr>
-              <a:spcBef>
-                <a:spcPts val="200"/>
-              </a:spcBef>
-            </a:pPr>
-            <a:r>
-              <a:rPr sz="1000" b="0">
-                <a:solidFill>
-                  <a:srgbClr val="334155"/>
-                </a:solidFill>
-                <a:latin typeface="Calibri"/>
-              </a:rPr>
-              <a:t>publish_preview ★</a:t>
-            </a:r>
-          </a:p>
-        </p:txBody>
-      </p:sp>
-      <p:sp>
-        <p:nvSpPr>
-          <p:cNvPr id="24" name="Rounded Rectangle 23"/>
-          <p:cNvSpPr/>
-          <p:nvPr/>
-        </p:nvSpPr>
-        <p:spPr>
-          <a:xfrm>
-            <a:off x="274320" y="4206240"/>
-            <a:ext cx="5623560" cy="2240280"/>
-          </a:xfrm>
-          <a:prstGeom prst="roundRect">
-            <a:avLst>
-              <a:gd name="adj" fmla="val 3000"/>
-            </a:avLst>
-          </a:prstGeom>
-          <a:solidFill>
-            <a:srgbClr val="ECFDF5"/>
-          </a:solidFill>
-          <a:ln w="15875">
-            <a:solidFill>
-              <a:srgbClr val="CBD5E1"/>
-            </a:solidFill>
-          </a:ln>
-        </p:spPr>
-        <p:style>
-          <a:lnRef idx="1">
-            <a:schemeClr val="accent1"/>
-          </a:lnRef>
-          <a:fillRef idx="3">
-            <a:schemeClr val="accent1"/>
-          </a:fillRef>
-          <a:effectRef idx="2">
-            <a:schemeClr val="accent1"/>
-          </a:effectRef>
-          <a:fontRef idx="minor">
-            <a:schemeClr val="lt1"/>
-          </a:fontRef>
-        </p:style>
-        <p:txBody>
-          <a:bodyPr rtlCol="0" anchor="ctr"/>
-          <a:lstStyle/>
-          <a:p>
-            <a:pPr algn="ctr"/>
-          </a:p>
-        </p:txBody>
-      </p:sp>
-      <p:sp>
-        <p:nvSpPr>
-          <p:cNvPr id="25" name="TextBox 24"/>
-          <p:cNvSpPr txBox="1"/>
-          <p:nvPr/>
-        </p:nvSpPr>
-        <p:spPr>
-          <a:xfrm>
-            <a:off x="384048" y="4279392"/>
-            <a:ext cx="5440680" cy="274320"/>
-          </a:xfrm>
-          <a:prstGeom prst="rect">
-            <a:avLst/>
-          </a:prstGeom>
-          <a:noFill/>
-        </p:spPr>
-        <p:txBody>
-          <a:bodyPr wrap="square">
-            <a:spAutoFit/>
-          </a:bodyPr>
-          <a:lstStyle/>
-          <a:p>
-            <a:r>
-              <a:rPr sz="1100" b="1">
-                <a:solidFill>
-                  <a:srgbClr val="64748B"/>
-                </a:solidFill>
-                <a:latin typeface="Calibri"/>
-              </a:rPr>
-              <a:t>③ 文件域</a:t>
-            </a:r>
-          </a:p>
-        </p:txBody>
-      </p:sp>
-      <p:sp>
-        <p:nvSpPr>
-          <p:cNvPr id="26" name="Rounded Rectangle 25"/>
-          <p:cNvSpPr/>
-          <p:nvPr/>
-        </p:nvSpPr>
-        <p:spPr>
-          <a:xfrm>
-            <a:off x="457200" y="4572000"/>
-            <a:ext cx="2606040" cy="1645920"/>
-          </a:xfrm>
-          <a:prstGeom prst="roundRect">
-            <a:avLst>
-              <a:gd name="adj" fmla="val 8000"/>
-            </a:avLst>
-          </a:prstGeom>
-          <a:solidFill>
-            <a:srgbClr val="FFFFFF"/>
-          </a:solidFill>
-          <a:ln w="15875">
-            <a:solidFill>
-              <a:srgbClr val="0D9488"/>
-            </a:solidFill>
-          </a:ln>
-        </p:spPr>
-        <p:style>
-          <a:lnRef idx="1">
-            <a:schemeClr val="accent1"/>
-          </a:lnRef>
-          <a:fillRef idx="3">
-            <a:schemeClr val="accent1"/>
-          </a:fillRef>
-          <a:effectRef idx="2">
-            <a:schemeClr val="accent1"/>
-          </a:effectRef>
-          <a:fontRef idx="minor">
-            <a:schemeClr val="lt1"/>
-          </a:fontRef>
-        </p:style>
-        <p:txBody>
-          <a:bodyPr rtlCol="0" anchor="ctr"/>
-          <a:lstStyle/>
-          <a:p>
-            <a:pPr algn="ctr"/>
-          </a:p>
-        </p:txBody>
-      </p:sp>
-      <p:sp>
-        <p:nvSpPr>
-          <p:cNvPr id="27" name="TextBox 26"/>
-          <p:cNvSpPr txBox="1"/>
-          <p:nvPr/>
-        </p:nvSpPr>
-        <p:spPr>
-          <a:xfrm>
-            <a:off x="566928" y="4663440"/>
-            <a:ext cx="2404872" cy="1499616"/>
-          </a:xfrm>
-          <a:prstGeom prst="rect">
-            <a:avLst/>
-          </a:prstGeom>
-          <a:noFill/>
-        </p:spPr>
-        <p:txBody>
-          <a:bodyPr wrap="square">
-            <a:spAutoFit/>
-          </a:bodyPr>
-          <a:lstStyle/>
-          <a:p>
-            <a:r>
-              <a:rPr sz="1200" b="1">
-                <a:solidFill>
-                  <a:srgbClr val="0F766E"/>
-                </a:solidFill>
-                <a:latin typeface="Calibri"/>
-              </a:rPr>
-              <a:t>Workspace</a:t>
-            </a:r>
-          </a:p>
-          <a:p>
-            <a:pPr>
-              <a:spcBef>
-                <a:spcPts val="200"/>
-              </a:spcBef>
-            </a:pPr>
-            <a:r>
-              <a:rPr sz="1000" b="0">
-                <a:solidFill>
-                  <a:srgbClr val="334155"/>
-                </a:solidFill>
-                <a:latin typeface="Calibri"/>
-              </a:rPr>
-              <a:t>本地/运行时工作区</a:t>
-            </a:r>
-          </a:p>
-          <a:p>
-            <a:pPr>
-              <a:spcBef>
-                <a:spcPts val="200"/>
-              </a:spcBef>
-            </a:pPr>
-            <a:r>
-              <a:rPr sz="1000" b="0">
-                <a:solidFill>
-                  <a:srgbClr val="334155"/>
-                </a:solidFill>
-                <a:latin typeface="Calibri"/>
-              </a:rPr>
-              <a:t>artifacts/ 产物</a:t>
-            </a:r>
-          </a:p>
-        </p:txBody>
-      </p:sp>
-      <p:sp>
-        <p:nvSpPr>
-          <p:cNvPr id="28" name="Rounded Rectangle 27"/>
-          <p:cNvSpPr/>
-          <p:nvPr/>
-        </p:nvSpPr>
-        <p:spPr>
-          <a:xfrm>
-            <a:off x="3200400" y="4572000"/>
-            <a:ext cx="2468880" cy="1645920"/>
-          </a:xfrm>
-          <a:prstGeom prst="roundRect">
-            <a:avLst>
-              <a:gd name="adj" fmla="val 8000"/>
-            </a:avLst>
-          </a:prstGeom>
-          <a:solidFill>
-            <a:srgbClr val="FFFFFF"/>
-          </a:solidFill>
-          <a:ln w="15875">
-            <a:solidFill>
-              <a:srgbClr val="0D9488"/>
-            </a:solidFill>
-          </a:ln>
-        </p:spPr>
-        <p:style>
-          <a:lnRef idx="1">
-            <a:schemeClr val="accent1"/>
-          </a:lnRef>
-          <a:fillRef idx="3">
-            <a:schemeClr val="accent1"/>
-          </a:fillRef>
-          <a:effectRef idx="2">
-            <a:schemeClr val="accent1"/>
-          </a:effectRef>
-          <a:fontRef idx="minor">
-            <a:schemeClr val="lt1"/>
-          </a:fontRef>
-        </p:style>
-        <p:txBody>
-          <a:bodyPr rtlCol="0" anchor="ctr"/>
-          <a:lstStyle/>
-          <a:p>
-            <a:pPr algn="ctr"/>
-          </a:p>
-        </p:txBody>
-      </p:sp>
-      <p:sp>
-        <p:nvSpPr>
-          <p:cNvPr id="29" name="TextBox 28"/>
-          <p:cNvSpPr txBox="1"/>
-          <p:nvPr/>
-        </p:nvSpPr>
-        <p:spPr>
-          <a:xfrm>
-            <a:off x="3310128" y="4663440"/>
-            <a:ext cx="2267712" cy="1499616"/>
-          </a:xfrm>
-          <a:prstGeom prst="rect">
-            <a:avLst/>
-          </a:prstGeom>
-          <a:noFill/>
-        </p:spPr>
-        <p:txBody>
-          <a:bodyPr wrap="square">
-            <a:spAutoFit/>
-          </a:bodyPr>
-          <a:lstStyle/>
-          <a:p>
-            <a:r>
-              <a:rPr sz="1200" b="1">
-                <a:solidFill>
-                  <a:srgbClr val="0F766E"/>
-                </a:solidFill>
-                <a:latin typeface="Calibri"/>
-              </a:rPr>
-              <a:t>华为云空间</a:t>
-            </a:r>
-          </a:p>
-          <a:p>
-            <a:pPr>
-              <a:spcBef>
-                <a:spcPts val="200"/>
-              </a:spcBef>
-            </a:pPr>
-            <a:r>
-              <a:rPr sz="1000" b="0">
-                <a:solidFill>
-                  <a:srgbClr val="334155"/>
-                </a:solidFill>
-                <a:latin typeface="Calibri"/>
-              </a:rPr>
-              <a:t>源文件持久化</a:t>
-            </a:r>
-          </a:p>
-          <a:p>
-            <a:pPr>
-              <a:spcBef>
-                <a:spcPts val="200"/>
-              </a:spcBef>
-            </a:pPr>
-            <a:r>
-              <a:rPr sz="1000" b="0">
-                <a:solidFill>
-                  <a:srgbClr val="334155"/>
-                </a:solidFill>
-                <a:latin typeface="Calibri"/>
-              </a:rPr>
-              <a:t>REST 元数据/下载</a:t>
-            </a:r>
-          </a:p>
-          <a:p>
-            <a:pPr>
-              <a:spcBef>
-                <a:spcPts val="200"/>
-              </a:spcBef>
-            </a:pPr>
-            <a:r>
-              <a:rPr sz="1000" b="0">
-                <a:solidFill>
-                  <a:srgbClr val="334155"/>
-                </a:solidFill>
-                <a:latin typeface="Calibri"/>
-              </a:rPr>
-              <a:t>非必须当网站主机</a:t>
-            </a:r>
-          </a:p>
-        </p:txBody>
-      </p:sp>
-      <p:sp>
-        <p:nvSpPr>
-          <p:cNvPr id="30" name="Rounded Rectangle 29"/>
-          <p:cNvSpPr/>
-          <p:nvPr/>
-        </p:nvSpPr>
-        <p:spPr>
-          <a:xfrm>
-            <a:off x="6035040" y="4206240"/>
-            <a:ext cx="5852160" cy="2240280"/>
-          </a:xfrm>
-          <a:prstGeom prst="roundRect">
-            <a:avLst>
-              <a:gd name="adj" fmla="val 3000"/>
-            </a:avLst>
-          </a:prstGeom>
-          <a:solidFill>
-            <a:srgbClr val="F0FDFA"/>
-          </a:solidFill>
-          <a:ln w="15875">
-            <a:solidFill>
-              <a:srgbClr val="CBD5E1"/>
-            </a:solidFill>
-          </a:ln>
-        </p:spPr>
-        <p:style>
-          <a:lnRef idx="1">
-            <a:schemeClr val="accent1"/>
-          </a:lnRef>
-          <a:fillRef idx="3">
-            <a:schemeClr val="accent1"/>
-          </a:fillRef>
-          <a:effectRef idx="2">
-            <a:schemeClr val="accent1"/>
-          </a:effectRef>
-          <a:fontRef idx="minor">
-            <a:schemeClr val="lt1"/>
-          </a:fontRef>
-        </p:style>
-        <p:txBody>
-          <a:bodyPr rtlCol="0" anchor="ctr"/>
-          <a:lstStyle/>
-          <a:p>
-            <a:pPr algn="ctr"/>
-          </a:p>
-        </p:txBody>
-      </p:sp>
-      <p:sp>
-        <p:nvSpPr>
-          <p:cNvPr id="31" name="TextBox 30"/>
-          <p:cNvSpPr txBox="1"/>
-          <p:nvPr/>
-        </p:nvSpPr>
-        <p:spPr>
-          <a:xfrm>
-            <a:off x="6144768" y="4279392"/>
-            <a:ext cx="5669280" cy="274320"/>
-          </a:xfrm>
-          <a:prstGeom prst="rect">
-            <a:avLst/>
-          </a:prstGeom>
-          <a:noFill/>
-        </p:spPr>
-        <p:txBody>
-          <a:bodyPr wrap="square">
-            <a:spAutoFit/>
-          </a:bodyPr>
-          <a:lstStyle/>
-          <a:p>
-            <a:r>
-              <a:rPr sz="1100" b="1">
-                <a:solidFill>
-                  <a:srgbClr val="64748B"/>
-                </a:solidFill>
-                <a:latin typeface="Calibri"/>
-              </a:rPr>
-              <a:t>④ Web 渲染中台（方案4）★</a:t>
-            </a:r>
-          </a:p>
-        </p:txBody>
-      </p:sp>
-      <p:sp>
-        <p:nvSpPr>
-          <p:cNvPr id="32" name="Rounded Rectangle 31"/>
-          <p:cNvSpPr/>
-          <p:nvPr/>
-        </p:nvSpPr>
-        <p:spPr>
-          <a:xfrm>
-            <a:off x="6217920" y="4572000"/>
-            <a:ext cx="5440680" cy="1645920"/>
-          </a:xfrm>
-          <a:prstGeom prst="roundRect">
-            <a:avLst>
-              <a:gd name="adj" fmla="val 8000"/>
-            </a:avLst>
-          </a:prstGeom>
-          <a:solidFill>
-            <a:srgbClr val="FFFFFF"/>
-          </a:solidFill>
-          <a:ln w="15875">
-            <a:solidFill>
-              <a:srgbClr val="0F766E"/>
-            </a:solidFill>
-          </a:ln>
-        </p:spPr>
-        <p:style>
-          <a:lnRef idx="1">
-            <a:schemeClr val="accent1"/>
-          </a:lnRef>
-          <a:fillRef idx="3">
-            <a:schemeClr val="accent1"/>
-          </a:fillRef>
-          <a:effectRef idx="2">
-            <a:schemeClr val="accent1"/>
-          </a:effectRef>
-          <a:fontRef idx="minor">
-            <a:schemeClr val="lt1"/>
-          </a:fontRef>
-        </p:style>
-        <p:txBody>
-          <a:bodyPr rtlCol="0" anchor="ctr"/>
-          <a:lstStyle/>
-          <a:p>
-            <a:pPr algn="ctr"/>
-          </a:p>
-        </p:txBody>
-      </p:sp>
-      <p:sp>
-        <p:nvSpPr>
-          <p:cNvPr id="33" name="TextBox 32"/>
-          <p:cNvSpPr txBox="1"/>
-          <p:nvPr/>
-        </p:nvSpPr>
-        <p:spPr>
-          <a:xfrm>
-            <a:off x="6327648" y="4663440"/>
-            <a:ext cx="5239512" cy="1499616"/>
-          </a:xfrm>
-          <a:prstGeom prst="rect">
-            <a:avLst/>
-          </a:prstGeom>
-          <a:noFill/>
-        </p:spPr>
-        <p:txBody>
-          <a:bodyPr wrap="square">
-            <a:spAutoFit/>
-          </a:bodyPr>
-          <a:lstStyle/>
-          <a:p>
-            <a:r>
-              <a:rPr sz="1200" b="1">
-                <a:solidFill>
-                  <a:srgbClr val="0F766E"/>
-                </a:solidFill>
-                <a:latin typeface="Calibri"/>
-              </a:rPr>
-              <a:t>Preview Web Service</a:t>
-            </a:r>
-          </a:p>
-          <a:p>
-            <a:pPr>
-              <a:spcBef>
-                <a:spcPts val="200"/>
-              </a:spcBef>
-            </a:pPr>
-            <a:r>
-              <a:rPr sz="1000" b="0">
-                <a:solidFill>
-                  <a:srgbClr val="334155"/>
-                </a:solidFill>
-                <a:latin typeface="Calibri"/>
-              </a:rPr>
-              <a:t>输入：HTML 或 file_id / 目录</a:t>
-            </a:r>
-          </a:p>
-          <a:p>
-            <a:pPr>
-              <a:spcBef>
-                <a:spcPts val="200"/>
-              </a:spcBef>
-            </a:pPr>
-            <a:r>
-              <a:rPr sz="1000" b="0">
-                <a:solidFill>
-                  <a:srgbClr val="334155"/>
-                </a:solidFill>
-                <a:latin typeface="Calibri"/>
-              </a:rPr>
-              <a:t>输出：可访问 preview_url</a:t>
-            </a:r>
-          </a:p>
-          <a:p>
-            <a:pPr>
-              <a:spcBef>
-                <a:spcPts val="200"/>
-              </a:spcBef>
-            </a:pPr>
-            <a:r>
-              <a:rPr sz="1000" b="0">
-                <a:solidFill>
-                  <a:srgbClr val="334155"/>
-                </a:solidFill>
-                <a:latin typeface="Calibri"/>
-              </a:rPr>
-              <a:t>职责：托管、MIME、CSP、TTL、多文件</a:t>
+              <a:t>流式方案 B/C（见备注，非本期主架构）</a:t>
             </a:r>
           </a:p>
         </p:txBody>
@@ -4909,7 +4023,7 @@
                 </a:solidFill>
                 <a:latin typeface="Calibri"/>
               </a:rPr>
-              <a:t>运行视图（草稿 · 请审）</a:t>
+              <a:t>逻辑架构图</a:t>
             </a:r>
           </a:p>
           <a:p>
@@ -4920,7 +4034,7 @@
                 </a:solidFill>
                 <a:latin typeface="Calibri"/>
               </a:rPr>
-              <a:t>健康报告端到端时序（方案4主路径；⑤ 云空间同步为推荐保留）</a:t>
+              <a:t>方案4主路径：Agent 直发独立预览服务 → 返回 URL → 端 WebView 渲染；云空间仅备份</a:t>
             </a:r>
           </a:p>
         </p:txBody>
@@ -4933,13 +4047,1334 @@
         </p:nvSpPr>
         <p:spPr>
           <a:xfrm>
-            <a:off x="320040" y="960120"/>
-            <a:ext cx="2148840" cy="411480"/>
+            <a:off x="274320" y="960120"/>
+            <a:ext cx="11612880" cy="1325880"/>
           </a:xfrm>
           <a:prstGeom prst="roundRect">
             <a:avLst>
-              <a:gd name="adj" fmla="val 20000"/>
+              <a:gd name="adj" fmla="val 3000"/>
             </a:avLst>
+          </a:prstGeom>
+          <a:solidFill>
+            <a:srgbClr val="EFF6FF"/>
+          </a:solidFill>
+          <a:ln w="15875">
+            <a:solidFill>
+              <a:srgbClr val="CBD5E1"/>
+            </a:solidFill>
+          </a:ln>
+        </p:spPr>
+        <p:style>
+          <a:lnRef idx="1">
+            <a:schemeClr val="accent1"/>
+          </a:lnRef>
+          <a:fillRef idx="3">
+            <a:schemeClr val="accent1"/>
+          </a:fillRef>
+          <a:effectRef idx="2">
+            <a:schemeClr val="accent1"/>
+          </a:effectRef>
+          <a:fontRef idx="minor">
+            <a:schemeClr val="lt1"/>
+          </a:fontRef>
+        </p:style>
+        <p:txBody>
+          <a:bodyPr rtlCol="0" anchor="ctr"/>
+          <a:lstStyle/>
+          <a:p>
+            <a:pPr algn="ctr"/>
+          </a:p>
+        </p:txBody>
+      </p:sp>
+      <p:sp>
+        <p:nvSpPr>
+          <p:cNvPr id="7" name="TextBox 6"/>
+          <p:cNvSpPr txBox="1"/>
+          <p:nvPr/>
+        </p:nvSpPr>
+        <p:spPr>
+          <a:xfrm>
+            <a:off x="384048" y="1033272"/>
+            <a:ext cx="11430000" cy="274320"/>
+          </a:xfrm>
+          <a:prstGeom prst="rect">
+            <a:avLst/>
+          </a:prstGeom>
+          <a:noFill/>
+        </p:spPr>
+        <p:txBody>
+          <a:bodyPr wrap="square">
+            <a:spAutoFit/>
+          </a:bodyPr>
+          <a:lstStyle/>
+          <a:p>
+            <a:r>
+              <a:rPr sz="1100" b="1">
+                <a:solidFill>
+                  <a:srgbClr val="64748B"/>
+                </a:solidFill>
+                <a:latin typeface="Calibri"/>
+              </a:rPr>
+              <a:t>① 端侧</a:t>
+            </a:r>
+          </a:p>
+        </p:txBody>
+      </p:sp>
+      <p:sp>
+        <p:nvSpPr>
+          <p:cNvPr id="8" name="Rounded Rectangle 7"/>
+          <p:cNvSpPr/>
+          <p:nvPr/>
+        </p:nvSpPr>
+        <p:spPr>
+          <a:xfrm>
+            <a:off x="502920" y="1280160"/>
+            <a:ext cx="5394960" cy="822960"/>
+          </a:xfrm>
+          <a:prstGeom prst="roundRect">
+            <a:avLst>
+              <a:gd name="adj" fmla="val 8000"/>
+            </a:avLst>
+          </a:prstGeom>
+          <a:solidFill>
+            <a:srgbClr val="FFFFFF"/>
+          </a:solidFill>
+          <a:ln w="15875">
+            <a:solidFill>
+              <a:srgbClr val="2563EB"/>
+            </a:solidFill>
+          </a:ln>
+        </p:spPr>
+        <p:style>
+          <a:lnRef idx="1">
+            <a:schemeClr val="accent1"/>
+          </a:lnRef>
+          <a:fillRef idx="3">
+            <a:schemeClr val="accent1"/>
+          </a:fillRef>
+          <a:effectRef idx="2">
+            <a:schemeClr val="accent1"/>
+          </a:effectRef>
+          <a:fontRef idx="minor">
+            <a:schemeClr val="lt1"/>
+          </a:fontRef>
+        </p:style>
+        <p:txBody>
+          <a:bodyPr rtlCol="0" anchor="ctr"/>
+          <a:lstStyle/>
+          <a:p>
+            <a:pPr algn="ctr"/>
+          </a:p>
+        </p:txBody>
+      </p:sp>
+      <p:sp>
+        <p:nvSpPr>
+          <p:cNvPr id="9" name="TextBox 8"/>
+          <p:cNvSpPr txBox="1"/>
+          <p:nvPr/>
+        </p:nvSpPr>
+        <p:spPr>
+          <a:xfrm>
+            <a:off x="612648" y="1371600"/>
+            <a:ext cx="5193792" cy="676656"/>
+          </a:xfrm>
+          <a:prstGeom prst="rect">
+            <a:avLst/>
+          </a:prstGeom>
+          <a:noFill/>
+        </p:spPr>
+        <p:txBody>
+          <a:bodyPr wrap="square">
+            <a:spAutoFit/>
+          </a:bodyPr>
+          <a:lstStyle/>
+          <a:p>
+            <a:r>
+              <a:rPr sz="1200" b="1">
+                <a:solidFill>
+                  <a:srgbClr val="2563EB"/>
+                </a:solidFill>
+                <a:latin typeface="Calibri"/>
+              </a:rPr>
+              <a:t>对话 UI</a:t>
+            </a:r>
+          </a:p>
+          <a:p>
+            <a:pPr>
+              <a:spcBef>
+                <a:spcPts val="300"/>
+              </a:spcBef>
+            </a:pPr>
+            <a:r>
+              <a:rPr sz="1100" b="0">
+                <a:solidFill>
+                  <a:srgbClr val="334155"/>
+                </a:solidFill>
+                <a:latin typeface="Calibri"/>
+              </a:rPr>
+              <a:t>发起任务；展示预览入口</a:t>
+            </a:r>
+          </a:p>
+        </p:txBody>
+      </p:sp>
+      <p:sp>
+        <p:nvSpPr>
+          <p:cNvPr id="10" name="Rounded Rectangle 9"/>
+          <p:cNvSpPr/>
+          <p:nvPr/>
+        </p:nvSpPr>
+        <p:spPr>
+          <a:xfrm>
+            <a:off x="6126480" y="1280160"/>
+            <a:ext cx="5440680" cy="822960"/>
+          </a:xfrm>
+          <a:prstGeom prst="roundRect">
+            <a:avLst>
+              <a:gd name="adj" fmla="val 8000"/>
+            </a:avLst>
+          </a:prstGeom>
+          <a:solidFill>
+            <a:srgbClr val="FFFFFF"/>
+          </a:solidFill>
+          <a:ln w="15875">
+            <a:solidFill>
+              <a:srgbClr val="0D9488"/>
+            </a:solidFill>
+          </a:ln>
+        </p:spPr>
+        <p:style>
+          <a:lnRef idx="1">
+            <a:schemeClr val="accent1"/>
+          </a:lnRef>
+          <a:fillRef idx="3">
+            <a:schemeClr val="accent1"/>
+          </a:fillRef>
+          <a:effectRef idx="2">
+            <a:schemeClr val="accent1"/>
+          </a:effectRef>
+          <a:fontRef idx="minor">
+            <a:schemeClr val="lt1"/>
+          </a:fontRef>
+        </p:style>
+        <p:txBody>
+          <a:bodyPr rtlCol="0" anchor="ctr"/>
+          <a:lstStyle/>
+          <a:p>
+            <a:pPr algn="ctr"/>
+          </a:p>
+        </p:txBody>
+      </p:sp>
+      <p:sp>
+        <p:nvSpPr>
+          <p:cNvPr id="11" name="TextBox 10"/>
+          <p:cNvSpPr txBox="1"/>
+          <p:nvPr/>
+        </p:nvSpPr>
+        <p:spPr>
+          <a:xfrm>
+            <a:off x="6236208" y="1371600"/>
+            <a:ext cx="5239512" cy="676656"/>
+          </a:xfrm>
+          <a:prstGeom prst="rect">
+            <a:avLst/>
+          </a:prstGeom>
+          <a:noFill/>
+        </p:spPr>
+        <p:txBody>
+          <a:bodyPr wrap="square">
+            <a:spAutoFit/>
+          </a:bodyPr>
+          <a:lstStyle/>
+          <a:p>
+            <a:r>
+              <a:rPr sz="1200" b="1">
+                <a:solidFill>
+                  <a:srgbClr val="0F766E"/>
+                </a:solidFill>
+                <a:latin typeface="Calibri"/>
+              </a:rPr>
+              <a:t>WebView 组件 ★</a:t>
+            </a:r>
+          </a:p>
+          <a:p>
+            <a:pPr>
+              <a:spcBef>
+                <a:spcPts val="300"/>
+              </a:spcBef>
+            </a:pPr>
+            <a:r>
+              <a:rPr sz="1100" b="0">
+                <a:solidFill>
+                  <a:srgbClr val="334155"/>
+                </a:solidFill>
+                <a:latin typeface="Calibri"/>
+              </a:rPr>
+              <a:t>loadUrl(preview_url) 会话内渲染</a:t>
+            </a:r>
+          </a:p>
+        </p:txBody>
+      </p:sp>
+      <p:sp>
+        <p:nvSpPr>
+          <p:cNvPr id="12" name="Rounded Rectangle 11"/>
+          <p:cNvSpPr/>
+          <p:nvPr/>
+        </p:nvSpPr>
+        <p:spPr>
+          <a:xfrm>
+            <a:off x="274320" y="2423160"/>
+            <a:ext cx="11612880" cy="1554480"/>
+          </a:xfrm>
+          <a:prstGeom prst="roundRect">
+            <a:avLst>
+              <a:gd name="adj" fmla="val 3000"/>
+            </a:avLst>
+          </a:prstGeom>
+          <a:solidFill>
+            <a:srgbClr val="F0FDFA"/>
+          </a:solidFill>
+          <a:ln w="15875">
+            <a:solidFill>
+              <a:srgbClr val="CBD5E1"/>
+            </a:solidFill>
+          </a:ln>
+        </p:spPr>
+        <p:style>
+          <a:lnRef idx="1">
+            <a:schemeClr val="accent1"/>
+          </a:lnRef>
+          <a:fillRef idx="3">
+            <a:schemeClr val="accent1"/>
+          </a:fillRef>
+          <a:effectRef idx="2">
+            <a:schemeClr val="accent1"/>
+          </a:effectRef>
+          <a:fontRef idx="minor">
+            <a:schemeClr val="lt1"/>
+          </a:fontRef>
+        </p:style>
+        <p:txBody>
+          <a:bodyPr rtlCol="0" anchor="ctr"/>
+          <a:lstStyle/>
+          <a:p>
+            <a:pPr algn="ctr"/>
+          </a:p>
+        </p:txBody>
+      </p:sp>
+      <p:sp>
+        <p:nvSpPr>
+          <p:cNvPr id="13" name="TextBox 12"/>
+          <p:cNvSpPr txBox="1"/>
+          <p:nvPr/>
+        </p:nvSpPr>
+        <p:spPr>
+          <a:xfrm>
+            <a:off x="384048" y="2496312"/>
+            <a:ext cx="11430000" cy="274320"/>
+          </a:xfrm>
+          <a:prstGeom prst="rect">
+            <a:avLst/>
+          </a:prstGeom>
+          <a:noFill/>
+        </p:spPr>
+        <p:txBody>
+          <a:bodyPr wrap="square">
+            <a:spAutoFit/>
+          </a:bodyPr>
+          <a:lstStyle/>
+          <a:p>
+            <a:r>
+              <a:rPr sz="1100" b="1">
+                <a:solidFill>
+                  <a:srgbClr val="64748B"/>
+                </a:solidFill>
+                <a:latin typeface="Calibri"/>
+              </a:rPr>
+              <a:t>② Agent 运行时</a:t>
+            </a:r>
+          </a:p>
+        </p:txBody>
+      </p:sp>
+      <p:sp>
+        <p:nvSpPr>
+          <p:cNvPr id="14" name="Rounded Rectangle 13"/>
+          <p:cNvSpPr/>
+          <p:nvPr/>
+        </p:nvSpPr>
+        <p:spPr>
+          <a:xfrm>
+            <a:off x="502920" y="2788920"/>
+            <a:ext cx="2697480" cy="1005840"/>
+          </a:xfrm>
+          <a:prstGeom prst="roundRect">
+            <a:avLst>
+              <a:gd name="adj" fmla="val 8000"/>
+            </a:avLst>
+          </a:prstGeom>
+          <a:solidFill>
+            <a:srgbClr val="FFFFFF"/>
+          </a:solidFill>
+          <a:ln w="15875">
+            <a:solidFill>
+              <a:srgbClr val="0D9488"/>
+            </a:solidFill>
+          </a:ln>
+        </p:spPr>
+        <p:style>
+          <a:lnRef idx="1">
+            <a:schemeClr val="accent1"/>
+          </a:lnRef>
+          <a:fillRef idx="3">
+            <a:schemeClr val="accent1"/>
+          </a:fillRef>
+          <a:effectRef idx="2">
+            <a:schemeClr val="accent1"/>
+          </a:effectRef>
+          <a:fontRef idx="minor">
+            <a:schemeClr val="lt1"/>
+          </a:fontRef>
+        </p:style>
+        <p:txBody>
+          <a:bodyPr rtlCol="0" anchor="ctr"/>
+          <a:lstStyle/>
+          <a:p>
+            <a:pPr algn="ctr"/>
+          </a:p>
+        </p:txBody>
+      </p:sp>
+      <p:sp>
+        <p:nvSpPr>
+          <p:cNvPr id="15" name="TextBox 14"/>
+          <p:cNvSpPr txBox="1"/>
+          <p:nvPr/>
+        </p:nvSpPr>
+        <p:spPr>
+          <a:xfrm>
+            <a:off x="612648" y="2880360"/>
+            <a:ext cx="2496312" cy="859536"/>
+          </a:xfrm>
+          <a:prstGeom prst="rect">
+            <a:avLst/>
+          </a:prstGeom>
+          <a:noFill/>
+        </p:spPr>
+        <p:txBody>
+          <a:bodyPr wrap="square">
+            <a:spAutoFit/>
+          </a:bodyPr>
+          <a:lstStyle/>
+          <a:p>
+            <a:r>
+              <a:rPr sz="1200" b="1">
+                <a:solidFill>
+                  <a:srgbClr val="0F766E"/>
+                </a:solidFill>
+                <a:latin typeface="Calibri"/>
+              </a:rPr>
+              <a:t>编排 / Session</a:t>
+            </a:r>
+          </a:p>
+          <a:p>
+            <a:pPr>
+              <a:spcBef>
+                <a:spcPts val="300"/>
+              </a:spcBef>
+            </a:pPr>
+            <a:r>
+              <a:rPr sz="1100" b="0">
+                <a:solidFill>
+                  <a:srgbClr val="334155"/>
+                </a:solidFill>
+                <a:latin typeface="Calibri"/>
+              </a:rPr>
+              <a:t>对话上下文</a:t>
+            </a:r>
+          </a:p>
+          <a:p>
+            <a:pPr>
+              <a:spcBef>
+                <a:spcPts val="300"/>
+              </a:spcBef>
+            </a:pPr>
+            <a:r>
+              <a:rPr sz="1100" b="0">
+                <a:solidFill>
+                  <a:srgbClr val="334155"/>
+                </a:solidFill>
+                <a:latin typeface="Calibri"/>
+              </a:rPr>
+              <a:t>工具调用编排</a:t>
+            </a:r>
+          </a:p>
+        </p:txBody>
+      </p:sp>
+      <p:sp>
+        <p:nvSpPr>
+          <p:cNvPr id="16" name="Rounded Rectangle 15"/>
+          <p:cNvSpPr/>
+          <p:nvPr/>
+        </p:nvSpPr>
+        <p:spPr>
+          <a:xfrm>
+            <a:off x="3337560" y="2788920"/>
+            <a:ext cx="2697480" cy="1005840"/>
+          </a:xfrm>
+          <a:prstGeom prst="roundRect">
+            <a:avLst>
+              <a:gd name="adj" fmla="val 8000"/>
+            </a:avLst>
+          </a:prstGeom>
+          <a:solidFill>
+            <a:srgbClr val="FFFFFF"/>
+          </a:solidFill>
+          <a:ln w="15875">
+            <a:solidFill>
+              <a:srgbClr val="0D9488"/>
+            </a:solidFill>
+          </a:ln>
+        </p:spPr>
+        <p:style>
+          <a:lnRef idx="1">
+            <a:schemeClr val="accent1"/>
+          </a:lnRef>
+          <a:fillRef idx="3">
+            <a:schemeClr val="accent1"/>
+          </a:fillRef>
+          <a:effectRef idx="2">
+            <a:schemeClr val="accent1"/>
+          </a:effectRef>
+          <a:fontRef idx="minor">
+            <a:schemeClr val="lt1"/>
+          </a:fontRef>
+        </p:style>
+        <p:txBody>
+          <a:bodyPr rtlCol="0" anchor="ctr"/>
+          <a:lstStyle/>
+          <a:p>
+            <a:pPr algn="ctr"/>
+          </a:p>
+        </p:txBody>
+      </p:sp>
+      <p:sp>
+        <p:nvSpPr>
+          <p:cNvPr id="17" name="TextBox 16"/>
+          <p:cNvSpPr txBox="1"/>
+          <p:nvPr/>
+        </p:nvSpPr>
+        <p:spPr>
+          <a:xfrm>
+            <a:off x="3447288" y="2880360"/>
+            <a:ext cx="2496312" cy="859536"/>
+          </a:xfrm>
+          <a:prstGeom prst="rect">
+            <a:avLst/>
+          </a:prstGeom>
+          <a:noFill/>
+        </p:spPr>
+        <p:txBody>
+          <a:bodyPr wrap="square">
+            <a:spAutoFit/>
+          </a:bodyPr>
+          <a:lstStyle/>
+          <a:p>
+            <a:r>
+              <a:rPr sz="1200" b="1">
+                <a:solidFill>
+                  <a:srgbClr val="0F766E"/>
+                </a:solidFill>
+                <a:latin typeface="Calibri"/>
+              </a:rPr>
+              <a:t>LLM</a:t>
+            </a:r>
+          </a:p>
+          <a:p>
+            <a:pPr>
+              <a:spcBef>
+                <a:spcPts val="300"/>
+              </a:spcBef>
+            </a:pPr>
+            <a:r>
+              <a:rPr sz="1100" b="0">
+                <a:solidFill>
+                  <a:srgbClr val="334155"/>
+                </a:solidFill>
+                <a:latin typeface="Calibri"/>
+              </a:rPr>
+              <a:t>生成单文件 HTML</a:t>
+            </a:r>
+          </a:p>
+          <a:p>
+            <a:pPr>
+              <a:spcBef>
+                <a:spcPts val="300"/>
+              </a:spcBef>
+            </a:pPr>
+            <a:r>
+              <a:rPr sz="1100" b="0">
+                <a:solidFill>
+                  <a:srgbClr val="334155"/>
+                </a:solidFill>
+                <a:latin typeface="Calibri"/>
+              </a:rPr>
+              <a:t>图表/文案内联</a:t>
+            </a:r>
+          </a:p>
+        </p:txBody>
+      </p:sp>
+      <p:sp>
+        <p:nvSpPr>
+          <p:cNvPr id="18" name="Rounded Rectangle 17"/>
+          <p:cNvSpPr/>
+          <p:nvPr/>
+        </p:nvSpPr>
+        <p:spPr>
+          <a:xfrm>
+            <a:off x="6172200" y="2788920"/>
+            <a:ext cx="2697480" cy="1005840"/>
+          </a:xfrm>
+          <a:prstGeom prst="roundRect">
+            <a:avLst>
+              <a:gd name="adj" fmla="val 8000"/>
+            </a:avLst>
+          </a:prstGeom>
+          <a:solidFill>
+            <a:srgbClr val="FFFFFF"/>
+          </a:solidFill>
+          <a:ln w="15875">
+            <a:solidFill>
+              <a:srgbClr val="0D9488"/>
+            </a:solidFill>
+          </a:ln>
+        </p:spPr>
+        <p:style>
+          <a:lnRef idx="1">
+            <a:schemeClr val="accent1"/>
+          </a:lnRef>
+          <a:fillRef idx="3">
+            <a:schemeClr val="accent1"/>
+          </a:fillRef>
+          <a:effectRef idx="2">
+            <a:schemeClr val="accent1"/>
+          </a:effectRef>
+          <a:fontRef idx="minor">
+            <a:schemeClr val="lt1"/>
+          </a:fontRef>
+        </p:style>
+        <p:txBody>
+          <a:bodyPr rtlCol="0" anchor="ctr"/>
+          <a:lstStyle/>
+          <a:p>
+            <a:pPr algn="ctr"/>
+          </a:p>
+        </p:txBody>
+      </p:sp>
+      <p:sp>
+        <p:nvSpPr>
+          <p:cNvPr id="19" name="TextBox 18"/>
+          <p:cNvSpPr txBox="1"/>
+          <p:nvPr/>
+        </p:nvSpPr>
+        <p:spPr>
+          <a:xfrm>
+            <a:off x="6281928" y="2880360"/>
+            <a:ext cx="2496312" cy="859536"/>
+          </a:xfrm>
+          <a:prstGeom prst="rect">
+            <a:avLst/>
+          </a:prstGeom>
+          <a:noFill/>
+        </p:spPr>
+        <p:txBody>
+          <a:bodyPr wrap="square">
+            <a:spAutoFit/>
+          </a:bodyPr>
+          <a:lstStyle/>
+          <a:p>
+            <a:r>
+              <a:rPr sz="1200" b="1">
+                <a:solidFill>
+                  <a:srgbClr val="0F766E"/>
+                </a:solidFill>
+                <a:latin typeface="Calibri"/>
+              </a:rPr>
+              <a:t>Skills</a:t>
+            </a:r>
+          </a:p>
+          <a:p>
+            <a:pPr>
+              <a:spcBef>
+                <a:spcPts val="300"/>
+              </a:spcBef>
+            </a:pPr>
+            <a:r>
+              <a:rPr sz="1100" b="0">
+                <a:solidFill>
+                  <a:srgbClr val="334155"/>
+                </a:solidFill>
+                <a:latin typeface="Calibri"/>
+              </a:rPr>
+              <a:t>运动健康数据 Skill</a:t>
+            </a:r>
+          </a:p>
+          <a:p>
+            <a:pPr>
+              <a:spcBef>
+                <a:spcPts val="300"/>
+              </a:spcBef>
+            </a:pPr>
+            <a:r>
+              <a:rPr sz="1100" b="0">
+                <a:solidFill>
+                  <a:srgbClr val="334155"/>
+                </a:solidFill>
+                <a:latin typeface="Calibri"/>
+              </a:rPr>
+              <a:t>其它取数…</a:t>
+            </a:r>
+          </a:p>
+        </p:txBody>
+      </p:sp>
+      <p:sp>
+        <p:nvSpPr>
+          <p:cNvPr id="20" name="Rounded Rectangle 19"/>
+          <p:cNvSpPr/>
+          <p:nvPr/>
+        </p:nvSpPr>
+        <p:spPr>
+          <a:xfrm>
+            <a:off x="9006840" y="2788920"/>
+            <a:ext cx="2606040" cy="1005840"/>
+          </a:xfrm>
+          <a:prstGeom prst="roundRect">
+            <a:avLst>
+              <a:gd name="adj" fmla="val 8000"/>
+            </a:avLst>
+          </a:prstGeom>
+          <a:solidFill>
+            <a:srgbClr val="FFFFFF"/>
+          </a:solidFill>
+          <a:ln w="15875">
+            <a:solidFill>
+              <a:srgbClr val="0F766E"/>
+            </a:solidFill>
+          </a:ln>
+        </p:spPr>
+        <p:style>
+          <a:lnRef idx="1">
+            <a:schemeClr val="accent1"/>
+          </a:lnRef>
+          <a:fillRef idx="3">
+            <a:schemeClr val="accent1"/>
+          </a:fillRef>
+          <a:effectRef idx="2">
+            <a:schemeClr val="accent1"/>
+          </a:effectRef>
+          <a:fontRef idx="minor">
+            <a:schemeClr val="lt1"/>
+          </a:fontRef>
+        </p:style>
+        <p:txBody>
+          <a:bodyPr rtlCol="0" anchor="ctr"/>
+          <a:lstStyle/>
+          <a:p>
+            <a:pPr algn="ctr"/>
+          </a:p>
+        </p:txBody>
+      </p:sp>
+      <p:sp>
+        <p:nvSpPr>
+          <p:cNvPr id="21" name="TextBox 20"/>
+          <p:cNvSpPr txBox="1"/>
+          <p:nvPr/>
+        </p:nvSpPr>
+        <p:spPr>
+          <a:xfrm>
+            <a:off x="9116568" y="2880360"/>
+            <a:ext cx="2404872" cy="859536"/>
+          </a:xfrm>
+          <a:prstGeom prst="rect">
+            <a:avLst/>
+          </a:prstGeom>
+          <a:noFill/>
+        </p:spPr>
+        <p:txBody>
+          <a:bodyPr wrap="square">
+            <a:spAutoFit/>
+          </a:bodyPr>
+          <a:lstStyle/>
+          <a:p>
+            <a:r>
+              <a:rPr sz="1200" b="1">
+                <a:solidFill>
+                  <a:srgbClr val="0F766E"/>
+                </a:solidFill>
+                <a:latin typeface="Calibri"/>
+              </a:rPr>
+              <a:t>Tools</a:t>
+            </a:r>
+          </a:p>
+          <a:p>
+            <a:pPr>
+              <a:spcBef>
+                <a:spcPts val="300"/>
+              </a:spcBef>
+            </a:pPr>
+            <a:r>
+              <a:rPr sz="1100" b="0">
+                <a:solidFill>
+                  <a:srgbClr val="334155"/>
+                </a:solidFill>
+                <a:latin typeface="Calibri"/>
+              </a:rPr>
+              <a:t>publish_preview ★</a:t>
+            </a:r>
+          </a:p>
+          <a:p>
+            <a:pPr>
+              <a:spcBef>
+                <a:spcPts val="300"/>
+              </a:spcBef>
+            </a:pPr>
+            <a:r>
+              <a:rPr sz="1100" b="0">
+                <a:solidFill>
+                  <a:srgbClr val="334155"/>
+                </a:solidFill>
+                <a:latin typeface="Calibri"/>
+              </a:rPr>
+              <a:t>write（备份云空间）</a:t>
+            </a:r>
+          </a:p>
+        </p:txBody>
+      </p:sp>
+      <p:sp>
+        <p:nvSpPr>
+          <p:cNvPr id="22" name="Rounded Rectangle 21"/>
+          <p:cNvSpPr/>
+          <p:nvPr/>
+        </p:nvSpPr>
+        <p:spPr>
+          <a:xfrm>
+            <a:off x="274320" y="4114800"/>
+            <a:ext cx="6766560" cy="2331720"/>
+          </a:xfrm>
+          <a:prstGeom prst="roundRect">
+            <a:avLst>
+              <a:gd name="adj" fmla="val 3000"/>
+            </a:avLst>
+          </a:prstGeom>
+          <a:solidFill>
+            <a:srgbClr val="F0FDFA"/>
+          </a:solidFill>
+          <a:ln w="15875">
+            <a:solidFill>
+              <a:srgbClr val="CBD5E1"/>
+            </a:solidFill>
+          </a:ln>
+        </p:spPr>
+        <p:style>
+          <a:lnRef idx="1">
+            <a:schemeClr val="accent1"/>
+          </a:lnRef>
+          <a:fillRef idx="3">
+            <a:schemeClr val="accent1"/>
+          </a:fillRef>
+          <a:effectRef idx="2">
+            <a:schemeClr val="accent1"/>
+          </a:effectRef>
+          <a:fontRef idx="minor">
+            <a:schemeClr val="lt1"/>
+          </a:fontRef>
+        </p:style>
+        <p:txBody>
+          <a:bodyPr rtlCol="0" anchor="ctr"/>
+          <a:lstStyle/>
+          <a:p>
+            <a:pPr algn="ctr"/>
+          </a:p>
+        </p:txBody>
+      </p:sp>
+      <p:sp>
+        <p:nvSpPr>
+          <p:cNvPr id="23" name="TextBox 22"/>
+          <p:cNvSpPr txBox="1"/>
+          <p:nvPr/>
+        </p:nvSpPr>
+        <p:spPr>
+          <a:xfrm>
+            <a:off x="384048" y="4187952"/>
+            <a:ext cx="6583680" cy="274320"/>
+          </a:xfrm>
+          <a:prstGeom prst="rect">
+            <a:avLst/>
+          </a:prstGeom>
+          <a:noFill/>
+        </p:spPr>
+        <p:txBody>
+          <a:bodyPr wrap="square">
+            <a:spAutoFit/>
+          </a:bodyPr>
+          <a:lstStyle/>
+          <a:p>
+            <a:r>
+              <a:rPr sz="1100" b="1">
+                <a:solidFill>
+                  <a:srgbClr val="64748B"/>
+                </a:solidFill>
+                <a:latin typeface="Calibri"/>
+              </a:rPr>
+              <a:t>③ Web 渲染中台（独立新服务）★</a:t>
+            </a:r>
+          </a:p>
+        </p:txBody>
+      </p:sp>
+      <p:sp>
+        <p:nvSpPr>
+          <p:cNvPr id="24" name="Rounded Rectangle 23"/>
+          <p:cNvSpPr/>
+          <p:nvPr/>
+        </p:nvSpPr>
+        <p:spPr>
+          <a:xfrm>
+            <a:off x="457200" y="4526280"/>
+            <a:ext cx="6355080" cy="1691640"/>
+          </a:xfrm>
+          <a:prstGeom prst="roundRect">
+            <a:avLst>
+              <a:gd name="adj" fmla="val 8000"/>
+            </a:avLst>
+          </a:prstGeom>
+          <a:solidFill>
+            <a:srgbClr val="FFFFFF"/>
+          </a:solidFill>
+          <a:ln w="15875">
+            <a:solidFill>
+              <a:srgbClr val="0F766E"/>
+            </a:solidFill>
+          </a:ln>
+        </p:spPr>
+        <p:style>
+          <a:lnRef idx="1">
+            <a:schemeClr val="accent1"/>
+          </a:lnRef>
+          <a:fillRef idx="3">
+            <a:schemeClr val="accent1"/>
+          </a:fillRef>
+          <a:effectRef idx="2">
+            <a:schemeClr val="accent1"/>
+          </a:effectRef>
+          <a:fontRef idx="minor">
+            <a:schemeClr val="lt1"/>
+          </a:fontRef>
+        </p:style>
+        <p:txBody>
+          <a:bodyPr rtlCol="0" anchor="ctr"/>
+          <a:lstStyle/>
+          <a:p>
+            <a:pPr algn="ctr"/>
+          </a:p>
+        </p:txBody>
+      </p:sp>
+      <p:sp>
+        <p:nvSpPr>
+          <p:cNvPr id="25" name="TextBox 24"/>
+          <p:cNvSpPr txBox="1"/>
+          <p:nvPr/>
+        </p:nvSpPr>
+        <p:spPr>
+          <a:xfrm>
+            <a:off x="566928" y="4617720"/>
+            <a:ext cx="6153912" cy="1545336"/>
+          </a:xfrm>
+          <a:prstGeom prst="rect">
+            <a:avLst/>
+          </a:prstGeom>
+          <a:noFill/>
+        </p:spPr>
+        <p:txBody>
+          <a:bodyPr wrap="square">
+            <a:spAutoFit/>
+          </a:bodyPr>
+          <a:lstStyle/>
+          <a:p>
+            <a:r>
+              <a:rPr sz="1200" b="1">
+                <a:solidFill>
+                  <a:srgbClr val="0F766E"/>
+                </a:solidFill>
+                <a:latin typeface="Calibri"/>
+              </a:rPr>
+              <a:t>Preview Web Service（独立部署）</a:t>
+            </a:r>
+          </a:p>
+          <a:p>
+            <a:pPr>
+              <a:spcBef>
+                <a:spcPts val="300"/>
+              </a:spcBef>
+            </a:pPr>
+            <a:r>
+              <a:rPr sz="1100" b="0">
+                <a:solidFill>
+                  <a:srgbClr val="334155"/>
+                </a:solidFill>
+                <a:latin typeface="Calibri"/>
+              </a:rPr>
+              <a:t>接收：Agent 直发的单文件 HTML</a:t>
+            </a:r>
+          </a:p>
+          <a:p>
+            <a:pPr>
+              <a:spcBef>
+                <a:spcPts val="300"/>
+              </a:spcBef>
+            </a:pPr>
+            <a:r>
+              <a:rPr sz="1100" b="0">
+                <a:solidFill>
+                  <a:srgbClr val="334155"/>
+                </a:solidFill>
+                <a:latin typeface="Calibri"/>
+              </a:rPr>
+              <a:t>输出：可访问 preview_url</a:t>
+            </a:r>
+          </a:p>
+          <a:p>
+            <a:pPr>
+              <a:spcBef>
+                <a:spcPts val="300"/>
+              </a:spcBef>
+            </a:pPr>
+            <a:r>
+              <a:rPr sz="1100" b="0">
+                <a:solidFill>
+                  <a:srgbClr val="334155"/>
+                </a:solidFill>
+                <a:latin typeface="Calibri"/>
+              </a:rPr>
+              <a:t>职责：托管、text/html、CSP、TTL、访问控制</a:t>
+            </a:r>
+          </a:p>
+        </p:txBody>
+      </p:sp>
+      <p:sp>
+        <p:nvSpPr>
+          <p:cNvPr id="26" name="Rounded Rectangle 25"/>
+          <p:cNvSpPr/>
+          <p:nvPr/>
+        </p:nvSpPr>
+        <p:spPr>
+          <a:xfrm>
+            <a:off x="7223760" y="4114800"/>
+            <a:ext cx="4663440" cy="2331720"/>
+          </a:xfrm>
+          <a:prstGeom prst="roundRect">
+            <a:avLst>
+              <a:gd name="adj" fmla="val 3000"/>
+            </a:avLst>
+          </a:prstGeom>
+          <a:solidFill>
+            <a:srgbClr val="ECFDF5"/>
+          </a:solidFill>
+          <a:ln w="15875">
+            <a:solidFill>
+              <a:srgbClr val="CBD5E1"/>
+            </a:solidFill>
+          </a:ln>
+        </p:spPr>
+        <p:style>
+          <a:lnRef idx="1">
+            <a:schemeClr val="accent1"/>
+          </a:lnRef>
+          <a:fillRef idx="3">
+            <a:schemeClr val="accent1"/>
+          </a:fillRef>
+          <a:effectRef idx="2">
+            <a:schemeClr val="accent1"/>
+          </a:effectRef>
+          <a:fontRef idx="minor">
+            <a:schemeClr val="lt1"/>
+          </a:fontRef>
+        </p:style>
+        <p:txBody>
+          <a:bodyPr rtlCol="0" anchor="ctr"/>
+          <a:lstStyle/>
+          <a:p>
+            <a:pPr algn="ctr"/>
+          </a:p>
+        </p:txBody>
+      </p:sp>
+      <p:sp>
+        <p:nvSpPr>
+          <p:cNvPr id="27" name="TextBox 26"/>
+          <p:cNvSpPr txBox="1"/>
+          <p:nvPr/>
+        </p:nvSpPr>
+        <p:spPr>
+          <a:xfrm>
+            <a:off x="7333488" y="4187952"/>
+            <a:ext cx="4480560" cy="274320"/>
+          </a:xfrm>
+          <a:prstGeom prst="rect">
+            <a:avLst/>
+          </a:prstGeom>
+          <a:noFill/>
+        </p:spPr>
+        <p:txBody>
+          <a:bodyPr wrap="square">
+            <a:spAutoFit/>
+          </a:bodyPr>
+          <a:lstStyle/>
+          <a:p>
+            <a:r>
+              <a:rPr sz="1100" b="1">
+                <a:solidFill>
+                  <a:srgbClr val="64748B"/>
+                </a:solidFill>
+                <a:latin typeface="Calibri"/>
+              </a:rPr>
+              <a:t>④ 备份（非渲染入口）</a:t>
+            </a:r>
+          </a:p>
+        </p:txBody>
+      </p:sp>
+      <p:sp>
+        <p:nvSpPr>
+          <p:cNvPr id="28" name="Rounded Rectangle 27"/>
+          <p:cNvSpPr/>
+          <p:nvPr/>
+        </p:nvSpPr>
+        <p:spPr>
+          <a:xfrm>
+            <a:off x="7406640" y="4526280"/>
+            <a:ext cx="4297680" cy="1691640"/>
+          </a:xfrm>
+          <a:prstGeom prst="roundRect">
+            <a:avLst>
+              <a:gd name="adj" fmla="val 8000"/>
+            </a:avLst>
+          </a:prstGeom>
+          <a:solidFill>
+            <a:srgbClr val="FFFFFF"/>
+          </a:solidFill>
+          <a:ln w="15875">
+            <a:solidFill>
+              <a:srgbClr val="0D9488"/>
+            </a:solidFill>
+          </a:ln>
+        </p:spPr>
+        <p:style>
+          <a:lnRef idx="1">
+            <a:schemeClr val="accent1"/>
+          </a:lnRef>
+          <a:fillRef idx="3">
+            <a:schemeClr val="accent1"/>
+          </a:fillRef>
+          <a:effectRef idx="2">
+            <a:schemeClr val="accent1"/>
+          </a:effectRef>
+          <a:fontRef idx="minor">
+            <a:schemeClr val="lt1"/>
+          </a:fontRef>
+        </p:style>
+        <p:txBody>
+          <a:bodyPr rtlCol="0" anchor="ctr"/>
+          <a:lstStyle/>
+          <a:p>
+            <a:pPr algn="ctr"/>
+          </a:p>
+        </p:txBody>
+      </p:sp>
+      <p:sp>
+        <p:nvSpPr>
+          <p:cNvPr id="29" name="TextBox 28"/>
+          <p:cNvSpPr txBox="1"/>
+          <p:nvPr/>
+        </p:nvSpPr>
+        <p:spPr>
+          <a:xfrm>
+            <a:off x="7516368" y="4617720"/>
+            <a:ext cx="4096512" cy="1545336"/>
+          </a:xfrm>
+          <a:prstGeom prst="rect">
+            <a:avLst/>
+          </a:prstGeom>
+          <a:noFill/>
+        </p:spPr>
+        <p:txBody>
+          <a:bodyPr wrap="square">
+            <a:spAutoFit/>
+          </a:bodyPr>
+          <a:lstStyle/>
+          <a:p>
+            <a:r>
+              <a:rPr sz="1200" b="1">
+                <a:solidFill>
+                  <a:srgbClr val="0F766E"/>
+                </a:solidFill>
+                <a:latin typeface="Calibri"/>
+              </a:rPr>
+              <a:t>华为云空间</a:t>
+            </a:r>
+          </a:p>
+          <a:p>
+            <a:pPr>
+              <a:spcBef>
+                <a:spcPts val="300"/>
+              </a:spcBef>
+            </a:pPr>
+            <a:r>
+              <a:rPr sz="1100" b="0">
+                <a:solidFill>
+                  <a:srgbClr val="334155"/>
+                </a:solidFill>
+                <a:latin typeface="Calibri"/>
+              </a:rPr>
+              <a:t>write 同步仅作备份/审计</a:t>
+            </a:r>
+          </a:p>
+          <a:p>
+            <a:pPr>
+              <a:spcBef>
+                <a:spcPts val="300"/>
+              </a:spcBef>
+            </a:pPr>
+            <a:r>
+              <a:rPr sz="1100" b="0">
+                <a:solidFill>
+                  <a:srgbClr val="334155"/>
+                </a:solidFill>
+                <a:latin typeface="Calibri"/>
+              </a:rPr>
+              <a:t>不承担 WebView 渲染入口</a:t>
+            </a:r>
+          </a:p>
+          <a:p>
+            <a:pPr>
+              <a:spcBef>
+                <a:spcPts val="300"/>
+              </a:spcBef>
+            </a:pPr>
+            <a:r>
+              <a:rPr sz="1100" b="0">
+                <a:solidFill>
+                  <a:srgbClr val="334155"/>
+                </a:solidFill>
+                <a:latin typeface="Calibri"/>
+              </a:rPr>
+              <a:t>需要时可 REST 取源文件</a:t>
+            </a:r>
+          </a:p>
+        </p:txBody>
+      </p:sp>
+      <p:sp>
+        <p:nvSpPr>
+          <p:cNvPr id="30" name="TextBox 29"/>
+          <p:cNvSpPr txBox="1"/>
+          <p:nvPr/>
+        </p:nvSpPr>
+        <p:spPr>
+          <a:xfrm>
+            <a:off x="365760" y="6537960"/>
+            <a:ext cx="11430000" cy="228600"/>
+          </a:xfrm>
+          <a:prstGeom prst="rect">
+            <a:avLst/>
+          </a:prstGeom>
+          <a:noFill/>
+        </p:spPr>
+        <p:txBody>
+          <a:bodyPr wrap="square">
+            <a:spAutoFit/>
+          </a:bodyPr>
+          <a:lstStyle/>
+          <a:p>
+            <a:r>
+              <a:rPr sz="1100" b="0">
+                <a:solidFill>
+                  <a:srgbClr val="64748B"/>
+                </a:solidFill>
+                <a:latin typeface="Calibri"/>
+              </a:rPr>
+              <a:t>鉴权注记：Agent→预览服务 可复用端云 AK/SK；WebView 打开 URL 更适合短时签名/一次性 token（见说明页）</a:t>
+            </a:r>
+          </a:p>
+        </p:txBody>
+      </p:sp>
+    </p:spTree>
+  </p:cSld>
+  <p:clrMapOvr>
+    <a:masterClrMapping/>
+  </p:clrMapOvr>
+</p:sld>
+</file>
+
+<file path=ppt/slides/slide3.xml><?xml version="1.0" encoding="utf-8"?>
+<p:sld xmlns:a="http://schemas.openxmlformats.org/drawingml/2006/main" xmlns:p="http://schemas.openxmlformats.org/presentationml/2006/main" xmlns:r="http://schemas.openxmlformats.org/officeDocument/2006/relationships">
+  <p:cSld>
+    <p:spTree>
+      <p:nvGrpSpPr>
+        <p:cNvPr id="1" name=""/>
+        <p:cNvGrpSpPr/>
+        <p:nvPr/>
+      </p:nvGrpSpPr>
+      <p:grpSpPr/>
+      <p:sp>
+        <p:nvSpPr>
+          <p:cNvPr id="2" name="Rectangle 1"/>
+          <p:cNvSpPr/>
+          <p:nvPr/>
+        </p:nvSpPr>
+        <p:spPr>
+          <a:xfrm>
+            <a:off x="0" y="0"/>
+            <a:ext cx="12191695" cy="6858000"/>
+          </a:xfrm>
+          <a:prstGeom prst="rect">
+            <a:avLst/>
+          </a:prstGeom>
+          <a:solidFill>
+            <a:srgbClr val="F8FAFC"/>
+          </a:solidFill>
+          <a:ln>
+            <a:noFill/>
+          </a:ln>
+        </p:spPr>
+        <p:style>
+          <a:lnRef idx="1">
+            <a:schemeClr val="accent1"/>
+          </a:lnRef>
+          <a:fillRef idx="3">
+            <a:schemeClr val="accent1"/>
+          </a:fillRef>
+          <a:effectRef idx="2">
+            <a:schemeClr val="accent1"/>
+          </a:effectRef>
+          <a:fontRef idx="minor">
+            <a:schemeClr val="lt1"/>
+          </a:fontRef>
+        </p:style>
+        <p:txBody>
+          <a:bodyPr rtlCol="0" anchor="ctr"/>
+          <a:lstStyle/>
+          <a:p>
+            <a:pPr algn="ctr"/>
+          </a:p>
+        </p:txBody>
+      </p:sp>
+      <p:sp>
+        <p:nvSpPr>
+          <p:cNvPr id="3" name="Rectangle 2"/>
+          <p:cNvSpPr/>
+          <p:nvPr/>
+        </p:nvSpPr>
+        <p:spPr>
+          <a:xfrm>
+            <a:off x="0" y="0"/>
+            <a:ext cx="12191695" cy="777240"/>
+          </a:xfrm>
+          <a:prstGeom prst="rect">
+            <a:avLst/>
           </a:prstGeom>
           <a:solidFill>
             <a:srgbClr val="0F172A"/>
@@ -4967,6 +5402,139 @@
           <a:lstStyle/>
           <a:p>
             <a:pPr algn="ctr"/>
+          </a:p>
+        </p:txBody>
+      </p:sp>
+      <p:sp>
+        <p:nvSpPr>
+          <p:cNvPr id="4" name="Rectangle 3"/>
+          <p:cNvSpPr/>
+          <p:nvPr/>
+        </p:nvSpPr>
+        <p:spPr>
+          <a:xfrm>
+            <a:off x="0" y="777240"/>
+            <a:ext cx="12191695" cy="45720"/>
+          </a:xfrm>
+          <a:prstGeom prst="rect">
+            <a:avLst/>
+          </a:prstGeom>
+          <a:solidFill>
+            <a:srgbClr val="0D9488"/>
+          </a:solidFill>
+          <a:ln>
+            <a:noFill/>
+          </a:ln>
+        </p:spPr>
+        <p:style>
+          <a:lnRef idx="1">
+            <a:schemeClr val="accent1"/>
+          </a:lnRef>
+          <a:fillRef idx="3">
+            <a:schemeClr val="accent1"/>
+          </a:fillRef>
+          <a:effectRef idx="2">
+            <a:schemeClr val="accent1"/>
+          </a:effectRef>
+          <a:fontRef idx="minor">
+            <a:schemeClr val="lt1"/>
+          </a:fontRef>
+        </p:style>
+        <p:txBody>
+          <a:bodyPr rtlCol="0" anchor="ctr"/>
+          <a:lstStyle/>
+          <a:p>
+            <a:pPr algn="ctr"/>
+          </a:p>
+        </p:txBody>
+      </p:sp>
+      <p:sp>
+        <p:nvSpPr>
+          <p:cNvPr id="5" name="TextBox 4"/>
+          <p:cNvSpPr txBox="1"/>
+          <p:nvPr/>
+        </p:nvSpPr>
+        <p:spPr>
+          <a:xfrm>
+            <a:off x="411480" y="164592"/>
+            <a:ext cx="11338560" cy="548640"/>
+          </a:xfrm>
+          <a:prstGeom prst="rect">
+            <a:avLst/>
+          </a:prstGeom>
+          <a:noFill/>
+        </p:spPr>
+        <p:txBody>
+          <a:bodyPr wrap="none">
+            <a:spAutoFit/>
+          </a:bodyPr>
+          <a:lstStyle/>
+          <a:p>
+            <a:r>
+              <a:rPr sz="2000" b="1">
+                <a:solidFill>
+                  <a:srgbClr val="FFFFFF"/>
+                </a:solidFill>
+                <a:latin typeface="Calibri"/>
+              </a:rPr>
+              <a:t>运行视图 · 健康报告</a:t>
+            </a:r>
+          </a:p>
+          <a:p>
+            <a:r>
+              <a:rPr sz="1100" b="0">
+                <a:solidFill>
+                  <a:srgbClr val="94A3B8"/>
+                </a:solidFill>
+                <a:latin typeface="Calibri"/>
+              </a:rPr>
+              <a:t>直发预览服务为主；云空间备份并行/事后；端仅 WebView 打开链接</a:t>
+            </a:r>
+          </a:p>
+        </p:txBody>
+      </p:sp>
+      <p:sp>
+        <p:nvSpPr>
+          <p:cNvPr id="6" name="Rounded Rectangle 5"/>
+          <p:cNvSpPr/>
+          <p:nvPr/>
+        </p:nvSpPr>
+        <p:spPr>
+          <a:xfrm>
+            <a:off x="320040" y="960120"/>
+            <a:ext cx="2148840" cy="411480"/>
+          </a:xfrm>
+          <a:prstGeom prst="roundRect">
+            <a:avLst>
+              <a:gd name="adj" fmla="val 20000"/>
+            </a:avLst>
+          </a:prstGeom>
+          <a:solidFill>
+            <a:srgbClr val="0F172A"/>
+          </a:solidFill>
+          <a:ln>
+            <a:noFill/>
+          </a:ln>
+        </p:spPr>
+        <p:style>
+          <a:lnRef idx="1">
+            <a:schemeClr val="accent1"/>
+          </a:lnRef>
+          <a:fillRef idx="3">
+            <a:schemeClr val="accent1"/>
+          </a:fillRef>
+          <a:effectRef idx="2">
+            <a:schemeClr val="accent1"/>
+          </a:effectRef>
+          <a:fontRef idx="minor">
+            <a:schemeClr val="lt1"/>
+          </a:fontRef>
+        </p:style>
+        <p:txBody>
+          <a:bodyPr rtlCol="0" anchor="ctr"/>
+          <a:lstStyle/>
+          <a:p>
+            <a:pPr algn="ctr"/>
             <a:r>
               <a:rPr sz="1100" b="1">
                 <a:solidFill>
@@ -4988,7 +5556,7 @@
         <p:spPr>
           <a:xfrm>
             <a:off x="1344168" y="1417320"/>
-            <a:ext cx="32004" cy="5074920"/>
+            <a:ext cx="32004" cy="4983480"/>
           </a:xfrm>
           <a:prstGeom prst="rect">
             <a:avLst/>
@@ -5085,7 +5653,7 @@
         <p:spPr>
           <a:xfrm>
             <a:off x="3675888" y="1417320"/>
-            <a:ext cx="32004" cy="5074920"/>
+            <a:ext cx="32004" cy="4983480"/>
           </a:xfrm>
           <a:prstGeom prst="rect">
             <a:avLst/>
@@ -5182,7 +5750,7 @@
         <p:spPr>
           <a:xfrm>
             <a:off x="6007608" y="1417320"/>
-            <a:ext cx="32004" cy="5074920"/>
+            <a:ext cx="32004" cy="4983480"/>
           </a:xfrm>
           <a:prstGeom prst="rect">
             <a:avLst/>
@@ -5265,7 +5833,7 @@
                 </a:solidFill>
                 <a:latin typeface="Calibri"/>
               </a:rPr>
-              <a:t>华为云空间</a:t>
+              <a:t>预览 Web 服务</a:t>
             </a:r>
           </a:p>
         </p:txBody>
@@ -5279,7 +5847,7 @@
         <p:spPr>
           <a:xfrm>
             <a:off x="8339328" y="1417320"/>
-            <a:ext cx="32004" cy="5074920"/>
+            <a:ext cx="32004" cy="4983480"/>
           </a:xfrm>
           <a:prstGeom prst="rect">
             <a:avLst/>
@@ -5362,7 +5930,7 @@
                 </a:solidFill>
                 <a:latin typeface="Calibri"/>
               </a:rPr>
-              <a:t>预览 Web 服务</a:t>
+              <a:t>云空间(备份)</a:t>
             </a:r>
           </a:p>
         </p:txBody>
@@ -5376,7 +5944,7 @@
         <p:spPr>
           <a:xfrm>
             <a:off x="10671048" y="1417320"/>
-            <a:ext cx="32004" cy="5074920"/>
+            <a:ext cx="32004" cy="4983480"/>
           </a:xfrm>
           <a:prstGeom prst="rect">
             <a:avLst/>
@@ -5621,7 +6189,7 @@
                 </a:solidFill>
                 <a:latin typeface="Calibri"/>
               </a:rPr>
-              <a:t>4. LLM 生成 HTML</a:t>
+              <a:t>4. LLM 生成单文件 HTML</a:t>
             </a:r>
           </a:p>
         </p:txBody>
@@ -5635,6 +6203,114 @@
         <p:spPr>
           <a:xfrm>
             <a:off x="7388352" y="3566160"/>
+            <a:ext cx="2011680" cy="384048"/>
+          </a:xfrm>
+          <a:prstGeom prst="roundRect">
+            <a:avLst>
+              <a:gd name="adj" fmla="val 20000"/>
+            </a:avLst>
+          </a:prstGeom>
+          <a:solidFill>
+            <a:srgbClr val="0F766E"/>
+          </a:solidFill>
+          <a:ln>
+            <a:noFill/>
+          </a:ln>
+        </p:spPr>
+        <p:style>
+          <a:lnRef idx="1">
+            <a:schemeClr val="accent1"/>
+          </a:lnRef>
+          <a:fillRef idx="3">
+            <a:schemeClr val="accent1"/>
+          </a:fillRef>
+          <a:effectRef idx="2">
+            <a:schemeClr val="accent1"/>
+          </a:effectRef>
+          <a:fontRef idx="minor">
+            <a:schemeClr val="lt1"/>
+          </a:fontRef>
+        </p:style>
+        <p:txBody>
+          <a:bodyPr rtlCol="0" anchor="ctr" wrap="square"/>
+          <a:lstStyle/>
+          <a:p>
+            <a:pPr algn="ctr"/>
+            <a:r>
+              <a:rPr sz="1000" b="1">
+                <a:solidFill>
+                  <a:srgbClr val="FFFFFF"/>
+                </a:solidFill>
+                <a:latin typeface="Calibri"/>
+              </a:rPr>
+              <a:t>5. publish_preview 直发</a:t>
+            </a:r>
+          </a:p>
+        </p:txBody>
+      </p:sp>
+      <p:sp>
+        <p:nvSpPr>
+          <p:cNvPr id="21" name="Rounded Rectangle 20"/>
+          <p:cNvSpPr/>
+          <p:nvPr/>
+        </p:nvSpPr>
+        <p:spPr>
+          <a:xfrm>
+            <a:off x="7388352" y="4069080"/>
+            <a:ext cx="2011680" cy="384048"/>
+          </a:xfrm>
+          <a:prstGeom prst="roundRect">
+            <a:avLst>
+              <a:gd name="adj" fmla="val 20000"/>
+            </a:avLst>
+          </a:prstGeom>
+          <a:solidFill>
+            <a:srgbClr val="0F766E"/>
+          </a:solidFill>
+          <a:ln>
+            <a:noFill/>
+          </a:ln>
+        </p:spPr>
+        <p:style>
+          <a:lnRef idx="1">
+            <a:schemeClr val="accent1"/>
+          </a:lnRef>
+          <a:fillRef idx="3">
+            <a:schemeClr val="accent1"/>
+          </a:fillRef>
+          <a:effectRef idx="2">
+            <a:schemeClr val="accent1"/>
+          </a:effectRef>
+          <a:fontRef idx="minor">
+            <a:schemeClr val="lt1"/>
+          </a:fontRef>
+        </p:style>
+        <p:txBody>
+          <a:bodyPr rtlCol="0" anchor="ctr" wrap="square"/>
+          <a:lstStyle/>
+          <a:p>
+            <a:pPr algn="ctr"/>
+            <a:r>
+              <a:rPr sz="1000" b="1">
+                <a:solidFill>
+                  <a:srgbClr val="FFFFFF"/>
+                </a:solidFill>
+                <a:latin typeface="Calibri"/>
+              </a:rPr>
+              <a:t>6. 返回 preview_url</a:t>
+            </a:r>
+          </a:p>
+        </p:txBody>
+      </p:sp>
+      <p:sp>
+        <p:nvSpPr>
+          <p:cNvPr id="22" name="Rounded Rectangle 21"/>
+          <p:cNvSpPr/>
+          <p:nvPr/>
+        </p:nvSpPr>
+        <p:spPr>
+          <a:xfrm>
+            <a:off x="9720072" y="4572000"/>
             <a:ext cx="2011680" cy="384048"/>
           </a:xfrm>
           <a:prstGeom prst="roundRect">
@@ -5675,115 +6351,7 @@
                 </a:solidFill>
                 <a:latin typeface="Calibri"/>
               </a:rPr>
-              <a:t>5. write 同步源文件</a:t>
-            </a:r>
-          </a:p>
-        </p:txBody>
-      </p:sp>
-      <p:sp>
-        <p:nvSpPr>
-          <p:cNvPr id="21" name="Rounded Rectangle 20"/>
-          <p:cNvSpPr/>
-          <p:nvPr/>
-        </p:nvSpPr>
-        <p:spPr>
-          <a:xfrm>
-            <a:off x="9720072" y="4069080"/>
-            <a:ext cx="2011680" cy="384048"/>
-          </a:xfrm>
-          <a:prstGeom prst="roundRect">
-            <a:avLst>
-              <a:gd name="adj" fmla="val 20000"/>
-            </a:avLst>
-          </a:prstGeom>
-          <a:solidFill>
-            <a:srgbClr val="0F766E"/>
-          </a:solidFill>
-          <a:ln>
-            <a:noFill/>
-          </a:ln>
-        </p:spPr>
-        <p:style>
-          <a:lnRef idx="1">
-            <a:schemeClr val="accent1"/>
-          </a:lnRef>
-          <a:fillRef idx="3">
-            <a:schemeClr val="accent1"/>
-          </a:fillRef>
-          <a:effectRef idx="2">
-            <a:schemeClr val="accent1"/>
-          </a:effectRef>
-          <a:fontRef idx="minor">
-            <a:schemeClr val="lt1"/>
-          </a:fontRef>
-        </p:style>
-        <p:txBody>
-          <a:bodyPr rtlCol="0" anchor="ctr" wrap="square"/>
-          <a:lstStyle/>
-          <a:p>
-            <a:pPr algn="ctr"/>
-            <a:r>
-              <a:rPr sz="1000" b="1">
-                <a:solidFill>
-                  <a:srgbClr val="FFFFFF"/>
-                </a:solidFill>
-                <a:latin typeface="Calibri"/>
-              </a:rPr>
-              <a:t>6. publish 页面</a:t>
-            </a:r>
-          </a:p>
-        </p:txBody>
-      </p:sp>
-      <p:sp>
-        <p:nvSpPr>
-          <p:cNvPr id="22" name="Rounded Rectangle 21"/>
-          <p:cNvSpPr/>
-          <p:nvPr/>
-        </p:nvSpPr>
-        <p:spPr>
-          <a:xfrm>
-            <a:off x="9720072" y="4572000"/>
-            <a:ext cx="2011680" cy="384048"/>
-          </a:xfrm>
-          <a:prstGeom prst="roundRect">
-            <a:avLst>
-              <a:gd name="adj" fmla="val 20000"/>
-            </a:avLst>
-          </a:prstGeom>
-          <a:solidFill>
-            <a:srgbClr val="0F766E"/>
-          </a:solidFill>
-          <a:ln>
-            <a:noFill/>
-          </a:ln>
-        </p:spPr>
-        <p:style>
-          <a:lnRef idx="1">
-            <a:schemeClr val="accent1"/>
-          </a:lnRef>
-          <a:fillRef idx="3">
-            <a:schemeClr val="accent1"/>
-          </a:fillRef>
-          <a:effectRef idx="2">
-            <a:schemeClr val="accent1"/>
-          </a:effectRef>
-          <a:fontRef idx="minor">
-            <a:schemeClr val="lt1"/>
-          </a:fontRef>
-        </p:style>
-        <p:txBody>
-          <a:bodyPr rtlCol="0" anchor="ctr" wrap="square"/>
-          <a:lstStyle/>
-          <a:p>
-            <a:pPr algn="ctr"/>
-            <a:r>
-              <a:rPr sz="1000" b="1">
-                <a:solidFill>
-                  <a:srgbClr val="FFFFFF"/>
-                </a:solidFill>
-                <a:latin typeface="Calibri"/>
-              </a:rPr>
-              <a:t>7. 签发 preview_url</a:t>
+              <a:t>7. write 备份源文件</a:t>
             </a:r>
           </a:p>
         </p:txBody>
@@ -5904,7 +6472,7 @@
         </p:nvSpPr>
         <p:spPr>
           <a:xfrm>
-            <a:off x="9720072" y="6080760"/>
+            <a:off x="7388352" y="6080760"/>
             <a:ext cx="2011680" cy="384048"/>
           </a:xfrm>
           <a:prstGeom prst="roundRect">
@@ -5979,7 +6547,1098 @@
                 </a:solidFill>
                 <a:latin typeface="Calibri"/>
               </a:rPr>
-              <a:t>实心步骤=主路径　　灰色步骤=推荐保留的源文件同步　　箭头语义：从上到下为时间顺序，卡片所在列为执行方</a:t>
+              <a:t>青色=主路径　　灰色=备份路径（可与 5/6 并行，不阻塞预览）　　WebView 访问预览 URL 的鉴权方式见说明页待定项</a:t>
+            </a:r>
+          </a:p>
+        </p:txBody>
+      </p:sp>
+    </p:spTree>
+  </p:cSld>
+  <p:clrMapOvr>
+    <a:masterClrMapping/>
+  </p:clrMapOvr>
+</p:sld>
+</file>
+
+<file path=ppt/slides/slide4.xml><?xml version="1.0" encoding="utf-8"?>
+<p:sld xmlns:a="http://schemas.openxmlformats.org/drawingml/2006/main" xmlns:p="http://schemas.openxmlformats.org/presentationml/2006/main" xmlns:r="http://schemas.openxmlformats.org/officeDocument/2006/relationships">
+  <p:cSld>
+    <p:spTree>
+      <p:nvGrpSpPr>
+        <p:cNvPr id="1" name=""/>
+        <p:cNvGrpSpPr/>
+        <p:nvPr/>
+      </p:nvGrpSpPr>
+      <p:grpSpPr/>
+      <p:sp>
+        <p:nvSpPr>
+          <p:cNvPr id="2" name="Rectangle 1"/>
+          <p:cNvSpPr/>
+          <p:nvPr/>
+        </p:nvSpPr>
+        <p:spPr>
+          <a:xfrm>
+            <a:off x="0" y="0"/>
+            <a:ext cx="12191695" cy="6858000"/>
+          </a:xfrm>
+          <a:prstGeom prst="rect">
+            <a:avLst/>
+          </a:prstGeom>
+          <a:solidFill>
+            <a:srgbClr val="F8FAFC"/>
+          </a:solidFill>
+          <a:ln>
+            <a:noFill/>
+          </a:ln>
+        </p:spPr>
+        <p:style>
+          <a:lnRef idx="1">
+            <a:schemeClr val="accent1"/>
+          </a:lnRef>
+          <a:fillRef idx="3">
+            <a:schemeClr val="accent1"/>
+          </a:fillRef>
+          <a:effectRef idx="2">
+            <a:schemeClr val="accent1"/>
+          </a:effectRef>
+          <a:fontRef idx="minor">
+            <a:schemeClr val="lt1"/>
+          </a:fontRef>
+        </p:style>
+        <p:txBody>
+          <a:bodyPr rtlCol="0" anchor="ctr"/>
+          <a:lstStyle/>
+          <a:p>
+            <a:pPr algn="ctr"/>
+          </a:p>
+        </p:txBody>
+      </p:sp>
+      <p:sp>
+        <p:nvSpPr>
+          <p:cNvPr id="3" name="Rectangle 2"/>
+          <p:cNvSpPr/>
+          <p:nvPr/>
+        </p:nvSpPr>
+        <p:spPr>
+          <a:xfrm>
+            <a:off x="0" y="0"/>
+            <a:ext cx="12191695" cy="777240"/>
+          </a:xfrm>
+          <a:prstGeom prst="rect">
+            <a:avLst/>
+          </a:prstGeom>
+          <a:solidFill>
+            <a:srgbClr val="0F172A"/>
+          </a:solidFill>
+          <a:ln>
+            <a:noFill/>
+          </a:ln>
+        </p:spPr>
+        <p:style>
+          <a:lnRef idx="1">
+            <a:schemeClr val="accent1"/>
+          </a:lnRef>
+          <a:fillRef idx="3">
+            <a:schemeClr val="accent1"/>
+          </a:fillRef>
+          <a:effectRef idx="2">
+            <a:schemeClr val="accent1"/>
+          </a:effectRef>
+          <a:fontRef idx="minor">
+            <a:schemeClr val="lt1"/>
+          </a:fontRef>
+        </p:style>
+        <p:txBody>
+          <a:bodyPr rtlCol="0" anchor="ctr"/>
+          <a:lstStyle/>
+          <a:p>
+            <a:pPr algn="ctr"/>
+          </a:p>
+        </p:txBody>
+      </p:sp>
+      <p:sp>
+        <p:nvSpPr>
+          <p:cNvPr id="4" name="Rectangle 3"/>
+          <p:cNvSpPr/>
+          <p:nvPr/>
+        </p:nvSpPr>
+        <p:spPr>
+          <a:xfrm>
+            <a:off x="0" y="777240"/>
+            <a:ext cx="12191695" cy="45720"/>
+          </a:xfrm>
+          <a:prstGeom prst="rect">
+            <a:avLst/>
+          </a:prstGeom>
+          <a:solidFill>
+            <a:srgbClr val="0D9488"/>
+          </a:solidFill>
+          <a:ln>
+            <a:noFill/>
+          </a:ln>
+        </p:spPr>
+        <p:style>
+          <a:lnRef idx="1">
+            <a:schemeClr val="accent1"/>
+          </a:lnRef>
+          <a:fillRef idx="3">
+            <a:schemeClr val="accent1"/>
+          </a:fillRef>
+          <a:effectRef idx="2">
+            <a:schemeClr val="accent1"/>
+          </a:effectRef>
+          <a:fontRef idx="minor">
+            <a:schemeClr val="lt1"/>
+          </a:fontRef>
+        </p:style>
+        <p:txBody>
+          <a:bodyPr rtlCol="0" anchor="ctr"/>
+          <a:lstStyle/>
+          <a:p>
+            <a:pPr algn="ctr"/>
+          </a:p>
+        </p:txBody>
+      </p:sp>
+      <p:sp>
+        <p:nvSpPr>
+          <p:cNvPr id="5" name="TextBox 4"/>
+          <p:cNvSpPr txBox="1"/>
+          <p:nvPr/>
+        </p:nvSpPr>
+        <p:spPr>
+          <a:xfrm>
+            <a:off x="411480" y="164592"/>
+            <a:ext cx="11338560" cy="548640"/>
+          </a:xfrm>
+          <a:prstGeom prst="rect">
+            <a:avLst/>
+          </a:prstGeom>
+          <a:noFill/>
+        </p:spPr>
+        <p:txBody>
+          <a:bodyPr wrap="none">
+            <a:spAutoFit/>
+          </a:bodyPr>
+          <a:lstStyle/>
+          <a:p>
+            <a:r>
+              <a:rPr sz="2000" b="1">
+                <a:solidFill>
+                  <a:srgbClr val="FFFFFF"/>
+                </a:solidFill>
+                <a:latin typeface="Calibri"/>
+              </a:rPr>
+              <a:t>说明：鉴权怎么选 · 单文件为何够用 · 流式 B/C 是什么</a:t>
+            </a:r>
+          </a:p>
+          <a:p>
+            <a:r>
+              <a:rPr sz="1100" b="0">
+                <a:solidFill>
+                  <a:srgbClr val="94A3B8"/>
+                </a:solidFill>
+                <a:latin typeface="Calibri"/>
+              </a:rPr>
+              <a:t>供对齐，不并入主 PPT</a:t>
+            </a:r>
+          </a:p>
+        </p:txBody>
+      </p:sp>
+      <p:sp>
+        <p:nvSpPr>
+          <p:cNvPr id="6" name="Rounded Rectangle 5"/>
+          <p:cNvSpPr/>
+          <p:nvPr/>
+        </p:nvSpPr>
+        <p:spPr>
+          <a:xfrm>
+            <a:off x="320040" y="1097280"/>
+            <a:ext cx="3794760" cy="5303520"/>
+          </a:xfrm>
+          <a:prstGeom prst="roundRect">
+            <a:avLst>
+              <a:gd name="adj" fmla="val 8000"/>
+            </a:avLst>
+          </a:prstGeom>
+          <a:solidFill>
+            <a:srgbClr val="F0FDFA"/>
+          </a:solidFill>
+          <a:ln w="15875">
+            <a:solidFill>
+              <a:srgbClr val="0D9488"/>
+            </a:solidFill>
+          </a:ln>
+        </p:spPr>
+        <p:style>
+          <a:lnRef idx="1">
+            <a:schemeClr val="accent1"/>
+          </a:lnRef>
+          <a:fillRef idx="3">
+            <a:schemeClr val="accent1"/>
+          </a:fillRef>
+          <a:effectRef idx="2">
+            <a:schemeClr val="accent1"/>
+          </a:effectRef>
+          <a:fontRef idx="minor">
+            <a:schemeClr val="lt1"/>
+          </a:fontRef>
+        </p:style>
+        <p:txBody>
+          <a:bodyPr rtlCol="0" anchor="ctr"/>
+          <a:lstStyle/>
+          <a:p>
+            <a:pPr algn="ctr"/>
+          </a:p>
+        </p:txBody>
+      </p:sp>
+      <p:sp>
+        <p:nvSpPr>
+          <p:cNvPr id="7" name="TextBox 6"/>
+          <p:cNvSpPr txBox="1"/>
+          <p:nvPr/>
+        </p:nvSpPr>
+        <p:spPr>
+          <a:xfrm>
+            <a:off x="429768" y="1188720"/>
+            <a:ext cx="3593592" cy="5157216"/>
+          </a:xfrm>
+          <a:prstGeom prst="rect">
+            <a:avLst/>
+          </a:prstGeom>
+          <a:noFill/>
+        </p:spPr>
+        <p:txBody>
+          <a:bodyPr wrap="square">
+            <a:spAutoFit/>
+          </a:bodyPr>
+          <a:lstStyle/>
+          <a:p>
+            <a:r>
+              <a:rPr sz="1200" b="1">
+                <a:solidFill>
+                  <a:srgbClr val="0F766E"/>
+                </a:solidFill>
+                <a:latin typeface="Calibri"/>
+              </a:rPr>
+              <a:t>鉴权建议（待你拍板）</a:t>
+            </a:r>
+          </a:p>
+          <a:p>
+            <a:pPr>
+              <a:spcBef>
+                <a:spcPts val="300"/>
+              </a:spcBef>
+            </a:pPr>
+            <a:r>
+              <a:rPr sz="1100" b="0">
+                <a:solidFill>
+                  <a:srgbClr val="334155"/>
+                </a:solidFill>
+                <a:latin typeface="Calibri"/>
+              </a:rPr>
+              <a:t>两条链路要分开看：</a:t>
+            </a:r>
+          </a:p>
+          <a:p>
+            <a:pPr>
+              <a:spcBef>
+                <a:spcPts val="300"/>
+              </a:spcBef>
+            </a:pPr>
+            <a:r>
+              <a:rPr sz="1100" b="0">
+                <a:solidFill>
+                  <a:srgbClr val="334155"/>
+                </a:solidFill>
+                <a:latin typeface="Calibri"/>
+              </a:rPr>
+              <a:t/>
+            </a:r>
+          </a:p>
+          <a:p>
+            <a:pPr>
+              <a:spcBef>
+                <a:spcPts val="300"/>
+              </a:spcBef>
+            </a:pPr>
+            <a:r>
+              <a:rPr sz="1100" b="0">
+                <a:solidFill>
+                  <a:srgbClr val="334155"/>
+                </a:solidFill>
+                <a:latin typeface="Calibri"/>
+              </a:rPr>
+              <a:t>A. Agent → 预览服务（服务间）</a:t>
+            </a:r>
+          </a:p>
+          <a:p>
+            <a:pPr>
+              <a:spcBef>
+                <a:spcPts val="300"/>
+              </a:spcBef>
+            </a:pPr>
+            <a:r>
+              <a:rPr sz="1100" b="0">
+                <a:solidFill>
+                  <a:srgbClr val="334155"/>
+                </a:solidFill>
+                <a:latin typeface="Calibri"/>
+              </a:rPr>
+              <a:t>  可复用现有端云 AK/SK</a:t>
+            </a:r>
+          </a:p>
+          <a:p>
+            <a:pPr>
+              <a:spcBef>
+                <a:spcPts val="300"/>
+              </a:spcBef>
+            </a:pPr>
+            <a:r>
+              <a:rPr sz="1100" b="0">
+                <a:solidFill>
+                  <a:srgbClr val="334155"/>
+                </a:solidFill>
+                <a:latin typeface="Calibri"/>
+              </a:rPr>
+              <a:t>  或内部服务凭证</a:t>
+            </a:r>
+          </a:p>
+          <a:p>
+            <a:pPr>
+              <a:spcBef>
+                <a:spcPts val="300"/>
+              </a:spcBef>
+            </a:pPr>
+            <a:r>
+              <a:rPr sz="1100" b="0">
+                <a:solidFill>
+                  <a:srgbClr val="334155"/>
+                </a:solidFill>
+                <a:latin typeface="Calibri"/>
+              </a:rPr>
+              <a:t/>
+            </a:r>
+          </a:p>
+          <a:p>
+            <a:pPr>
+              <a:spcBef>
+                <a:spcPts val="300"/>
+              </a:spcBef>
+            </a:pPr>
+            <a:r>
+              <a:rPr sz="1100" b="0">
+                <a:solidFill>
+                  <a:srgbClr val="334155"/>
+                </a:solidFill>
+                <a:latin typeface="Calibri"/>
+              </a:rPr>
+              <a:t>B. WebView → 打开 preview_url</a:t>
+            </a:r>
+          </a:p>
+          <a:p>
+            <a:pPr>
+              <a:spcBef>
+                <a:spcPts val="300"/>
+              </a:spcBef>
+            </a:pPr>
+            <a:r>
+              <a:rPr sz="1100" b="0">
+                <a:solidFill>
+                  <a:srgbClr val="334155"/>
+                </a:solidFill>
+                <a:latin typeface="Calibri"/>
+              </a:rPr>
+              <a:t>  不太适合直接塞 AK/SK</a:t>
+            </a:r>
+          </a:p>
+          <a:p>
+            <a:pPr>
+              <a:spcBef>
+                <a:spcPts val="300"/>
+              </a:spcBef>
+            </a:pPr>
+            <a:r>
+              <a:rPr sz="1100" b="0">
+                <a:solidFill>
+                  <a:srgbClr val="334155"/>
+                </a:solidFill>
+                <a:latin typeface="Calibri"/>
+              </a:rPr>
+              <a:t>  （密钥会进 WebView/日志）</a:t>
+            </a:r>
+          </a:p>
+          <a:p>
+            <a:pPr>
+              <a:spcBef>
+                <a:spcPts val="300"/>
+              </a:spcBef>
+            </a:pPr>
+            <a:r>
+              <a:rPr sz="1100" b="0">
+                <a:solidFill>
+                  <a:srgbClr val="334155"/>
+                </a:solidFill>
+                <a:latin typeface="Calibri"/>
+              </a:rPr>
+              <a:t/>
+            </a:r>
+          </a:p>
+          <a:p>
+            <a:pPr>
+              <a:spcBef>
+                <a:spcPts val="300"/>
+              </a:spcBef>
+            </a:pPr>
+            <a:r>
+              <a:rPr sz="1100" b="0">
+                <a:solidFill>
+                  <a:srgbClr val="334155"/>
+                </a:solidFill>
+                <a:latin typeface="Calibri"/>
+              </a:rPr>
+              <a:t>更常见：</a:t>
+            </a:r>
+          </a:p>
+          <a:p>
+            <a:pPr>
+              <a:spcBef>
+                <a:spcPts val="300"/>
+              </a:spcBef>
+            </a:pPr>
+            <a:r>
+              <a:rPr sz="1100" b="0">
+                <a:solidFill>
+                  <a:srgbClr val="334155"/>
+                </a:solidFill>
+                <a:latin typeface="Calibri"/>
+              </a:rPr>
+              <a:t>  publish 时用 AK/SK 鉴权</a:t>
+            </a:r>
+          </a:p>
+          <a:p>
+            <a:pPr>
+              <a:spcBef>
+                <a:spcPts val="300"/>
+              </a:spcBef>
+            </a:pPr>
+            <a:r>
+              <a:rPr sz="1100" b="0">
+                <a:solidFill>
+                  <a:srgbClr val="334155"/>
+                </a:solidFill>
+                <a:latin typeface="Calibri"/>
+              </a:rPr>
+              <a:t>  返回短时签名 URL / 一次性 token</a:t>
+            </a:r>
+          </a:p>
+          <a:p>
+            <a:pPr>
+              <a:spcBef>
+                <a:spcPts val="300"/>
+              </a:spcBef>
+            </a:pPr>
+            <a:r>
+              <a:rPr sz="1100" b="0">
+                <a:solidFill>
+                  <a:srgbClr val="334155"/>
+                </a:solidFill>
+                <a:latin typeface="Calibri"/>
+              </a:rPr>
+              <a:t>  WebView 只拿这个链接打开</a:t>
+            </a:r>
+          </a:p>
+        </p:txBody>
+      </p:sp>
+      <p:sp>
+        <p:nvSpPr>
+          <p:cNvPr id="8" name="Rounded Rectangle 7"/>
+          <p:cNvSpPr/>
+          <p:nvPr/>
+        </p:nvSpPr>
+        <p:spPr>
+          <a:xfrm>
+            <a:off x="4251960" y="1097280"/>
+            <a:ext cx="3794760" cy="5303520"/>
+          </a:xfrm>
+          <a:prstGeom prst="roundRect">
+            <a:avLst>
+              <a:gd name="adj" fmla="val 8000"/>
+            </a:avLst>
+          </a:prstGeom>
+          <a:solidFill>
+            <a:srgbClr val="FFFFFF"/>
+          </a:solidFill>
+          <a:ln w="15875">
+            <a:solidFill>
+              <a:srgbClr val="0D9488"/>
+            </a:solidFill>
+          </a:ln>
+        </p:spPr>
+        <p:style>
+          <a:lnRef idx="1">
+            <a:schemeClr val="accent1"/>
+          </a:lnRef>
+          <a:fillRef idx="3">
+            <a:schemeClr val="accent1"/>
+          </a:fillRef>
+          <a:effectRef idx="2">
+            <a:schemeClr val="accent1"/>
+          </a:effectRef>
+          <a:fontRef idx="minor">
+            <a:schemeClr val="lt1"/>
+          </a:fontRef>
+        </p:style>
+        <p:txBody>
+          <a:bodyPr rtlCol="0" anchor="ctr"/>
+          <a:lstStyle/>
+          <a:p>
+            <a:pPr algn="ctr"/>
+          </a:p>
+        </p:txBody>
+      </p:sp>
+      <p:sp>
+        <p:nvSpPr>
+          <p:cNvPr id="9" name="TextBox 8"/>
+          <p:cNvSpPr txBox="1"/>
+          <p:nvPr/>
+        </p:nvSpPr>
+        <p:spPr>
+          <a:xfrm>
+            <a:off x="4361688" y="1188720"/>
+            <a:ext cx="3593592" cy="5157216"/>
+          </a:xfrm>
+          <a:prstGeom prst="rect">
+            <a:avLst/>
+          </a:prstGeom>
+          <a:noFill/>
+        </p:spPr>
+        <p:txBody>
+          <a:bodyPr wrap="square">
+            <a:spAutoFit/>
+          </a:bodyPr>
+          <a:lstStyle/>
+          <a:p>
+            <a:r>
+              <a:rPr sz="1200" b="1">
+                <a:solidFill>
+                  <a:srgbClr val="0F766E"/>
+                </a:solidFill>
+                <a:latin typeface="Calibri"/>
+              </a:rPr>
+              <a:t>静态目录资源有啥用？</a:t>
+            </a:r>
+          </a:p>
+          <a:p>
+            <a:pPr>
+              <a:spcBef>
+                <a:spcPts val="300"/>
+              </a:spcBef>
+            </a:pPr>
+            <a:r>
+              <a:rPr sz="1100" b="0">
+                <a:solidFill>
+                  <a:srgbClr val="334155"/>
+                </a:solidFill>
+                <a:latin typeface="Calibri"/>
+              </a:rPr>
+              <a:t>指一个页面拆成：</a:t>
+            </a:r>
+          </a:p>
+          <a:p>
+            <a:pPr>
+              <a:spcBef>
+                <a:spcPts val="300"/>
+              </a:spcBef>
+            </a:pPr>
+            <a:r>
+              <a:rPr sz="1100" b="0">
+                <a:solidFill>
+                  <a:srgbClr val="334155"/>
+                </a:solidFill>
+                <a:latin typeface="Calibri"/>
+              </a:rPr>
+              <a:t>  index.html + app.css + chart.js</a:t>
+            </a:r>
+          </a:p>
+          <a:p>
+            <a:pPr>
+              <a:spcBef>
+                <a:spcPts val="300"/>
+              </a:spcBef>
+            </a:pPr>
+            <a:r>
+              <a:rPr sz="1100" b="0">
+                <a:solidFill>
+                  <a:srgbClr val="334155"/>
+                </a:solidFill>
+                <a:latin typeface="Calibri"/>
+              </a:rPr>
+              <a:t>  + 图片等多个文件</a:t>
+            </a:r>
+          </a:p>
+          <a:p>
+            <a:pPr>
+              <a:spcBef>
+                <a:spcPts val="300"/>
+              </a:spcBef>
+            </a:pPr>
+            <a:r>
+              <a:rPr sz="1100" b="0">
+                <a:solidFill>
+                  <a:srgbClr val="334155"/>
+                </a:solidFill>
+                <a:latin typeface="Calibri"/>
+              </a:rPr>
+              <a:t/>
+            </a:r>
+          </a:p>
+          <a:p>
+            <a:pPr>
+              <a:spcBef>
+                <a:spcPts val="300"/>
+              </a:spcBef>
+            </a:pPr>
+            <a:r>
+              <a:rPr sz="1100" b="0">
+                <a:solidFill>
+                  <a:srgbClr val="334155"/>
+                </a:solidFill>
+                <a:latin typeface="Calibri"/>
+              </a:rPr>
+              <a:t>预览服务若支持「目录托管」，</a:t>
+            </a:r>
+          </a:p>
+          <a:p>
+            <a:pPr>
+              <a:spcBef>
+                <a:spcPts val="300"/>
+              </a:spcBef>
+            </a:pPr>
+            <a:r>
+              <a:rPr sz="1100" b="0">
+                <a:solidFill>
+                  <a:srgbClr val="334155"/>
+                </a:solidFill>
+                <a:latin typeface="Calibri"/>
+              </a:rPr>
+              <a:t>相对路径才能一起打开。</a:t>
+            </a:r>
+          </a:p>
+          <a:p>
+            <a:pPr>
+              <a:spcBef>
+                <a:spcPts val="300"/>
+              </a:spcBef>
+            </a:pPr>
+            <a:r>
+              <a:rPr sz="1100" b="0">
+                <a:solidFill>
+                  <a:srgbClr val="334155"/>
+                </a:solidFill>
+                <a:latin typeface="Calibri"/>
+              </a:rPr>
+              <a:t/>
+            </a:r>
+          </a:p>
+          <a:p>
+            <a:pPr>
+              <a:spcBef>
+                <a:spcPts val="300"/>
+              </a:spcBef>
+            </a:pPr>
+            <a:r>
+              <a:rPr sz="1100" b="0">
+                <a:solidFill>
+                  <a:srgbClr val="334155"/>
+                </a:solidFill>
+                <a:latin typeface="Calibri"/>
+              </a:rPr>
+              <a:t>一期单文件：</a:t>
+            </a:r>
+          </a:p>
+          <a:p>
+            <a:pPr>
+              <a:spcBef>
+                <a:spcPts val="300"/>
+              </a:spcBef>
+            </a:pPr>
+            <a:r>
+              <a:rPr sz="1100" b="0">
+                <a:solidFill>
+                  <a:srgbClr val="334155"/>
+                </a:solidFill>
+                <a:latin typeface="Calibri"/>
+              </a:rPr>
+              <a:t>  CSS/JS 都写进同一个 HTML</a:t>
+            </a:r>
+          </a:p>
+          <a:p>
+            <a:pPr>
+              <a:spcBef>
+                <a:spcPts val="300"/>
+              </a:spcBef>
+            </a:pPr>
+            <a:r>
+              <a:rPr sz="1100" b="0">
+                <a:solidFill>
+                  <a:srgbClr val="334155"/>
+                </a:solidFill>
+                <a:latin typeface="Calibri"/>
+              </a:rPr>
+              <a:t>  → 不需要目录能力</a:t>
+            </a:r>
+          </a:p>
+          <a:p>
+            <a:pPr>
+              <a:spcBef>
+                <a:spcPts val="300"/>
+              </a:spcBef>
+            </a:pPr>
+            <a:r>
+              <a:rPr sz="1100" b="0">
+                <a:solidFill>
+                  <a:srgbClr val="334155"/>
+                </a:solidFill>
+                <a:latin typeface="Calibri"/>
+              </a:rPr>
+              <a:t/>
+            </a:r>
+          </a:p>
+          <a:p>
+            <a:pPr>
+              <a:spcBef>
+                <a:spcPts val="300"/>
+              </a:spcBef>
+            </a:pPr>
+            <a:r>
+              <a:rPr sz="1100" b="0">
+                <a:solidFill>
+                  <a:srgbClr val="334155"/>
+                </a:solidFill>
+                <a:latin typeface="Calibri"/>
+              </a:rPr>
+              <a:t>所以一期不做静态目录完全合理；</a:t>
+            </a:r>
+          </a:p>
+          <a:p>
+            <a:pPr>
+              <a:spcBef>
+                <a:spcPts val="300"/>
+              </a:spcBef>
+            </a:pPr>
+            <a:r>
+              <a:rPr sz="1100" b="0">
+                <a:solidFill>
+                  <a:srgbClr val="334155"/>
+                </a:solidFill>
+                <a:latin typeface="Calibri"/>
+              </a:rPr>
+              <a:t>以后报告变复杂再加即可。</a:t>
+            </a:r>
+          </a:p>
+        </p:txBody>
+      </p:sp>
+      <p:sp>
+        <p:nvSpPr>
+          <p:cNvPr id="10" name="Rounded Rectangle 9"/>
+          <p:cNvSpPr/>
+          <p:nvPr/>
+        </p:nvSpPr>
+        <p:spPr>
+          <a:xfrm>
+            <a:off x="8183879" y="1097280"/>
+            <a:ext cx="3657600" cy="5303520"/>
+          </a:xfrm>
+          <a:prstGeom prst="roundRect">
+            <a:avLst>
+              <a:gd name="adj" fmla="val 8000"/>
+            </a:avLst>
+          </a:prstGeom>
+          <a:solidFill>
+            <a:srgbClr val="FFFBEB"/>
+          </a:solidFill>
+          <a:ln w="15875">
+            <a:solidFill>
+              <a:srgbClr val="B45309"/>
+            </a:solidFill>
+          </a:ln>
+        </p:spPr>
+        <p:style>
+          <a:lnRef idx="1">
+            <a:schemeClr val="accent1"/>
+          </a:lnRef>
+          <a:fillRef idx="3">
+            <a:schemeClr val="accent1"/>
+          </a:fillRef>
+          <a:effectRef idx="2">
+            <a:schemeClr val="accent1"/>
+          </a:effectRef>
+          <a:fontRef idx="minor">
+            <a:schemeClr val="lt1"/>
+          </a:fontRef>
+        </p:style>
+        <p:txBody>
+          <a:bodyPr rtlCol="0" anchor="ctr"/>
+          <a:lstStyle/>
+          <a:p>
+            <a:pPr algn="ctr"/>
+          </a:p>
+        </p:txBody>
+      </p:sp>
+      <p:sp>
+        <p:nvSpPr>
+          <p:cNvPr id="11" name="TextBox 10"/>
+          <p:cNvSpPr txBox="1"/>
+          <p:nvPr/>
+        </p:nvSpPr>
+        <p:spPr>
+          <a:xfrm>
+            <a:off x="8293607" y="1188720"/>
+            <a:ext cx="3456432" cy="5157216"/>
+          </a:xfrm>
+          <a:prstGeom prst="rect">
+            <a:avLst/>
+          </a:prstGeom>
+          <a:noFill/>
+        </p:spPr>
+        <p:txBody>
+          <a:bodyPr wrap="square">
+            <a:spAutoFit/>
+          </a:bodyPr>
+          <a:lstStyle/>
+          <a:p>
+            <a:r>
+              <a:rPr sz="1200" b="1">
+                <a:solidFill>
+                  <a:srgbClr val="B45309"/>
+                </a:solidFill>
+                <a:latin typeface="Calibri"/>
+              </a:rPr>
+              <a:t>流式 B/C 是什么？</a:t>
+            </a:r>
+          </a:p>
+          <a:p>
+            <a:pPr>
+              <a:spcBef>
+                <a:spcPts val="300"/>
+              </a:spcBef>
+            </a:pPr>
+            <a:r>
+              <a:rPr sz="1100" b="0">
+                <a:solidFill>
+                  <a:srgbClr val="334155"/>
+                </a:solidFill>
+                <a:latin typeface="Calibri"/>
+              </a:rPr>
+              <a:t>这是主 PPT 里另外两条</a:t>
+            </a:r>
+          </a:p>
+          <a:p>
+            <a:pPr>
+              <a:spcBef>
+                <a:spcPts val="300"/>
+              </a:spcBef>
+            </a:pPr>
+            <a:r>
+              <a:rPr sz="1100" b="0">
+                <a:solidFill>
+                  <a:srgbClr val="334155"/>
+                </a:solidFill>
+                <a:latin typeface="Calibri"/>
+              </a:rPr>
+              <a:t>「端内喂 HTML」的备选，</a:t>
+            </a:r>
+          </a:p>
+          <a:p>
+            <a:pPr>
+              <a:spcBef>
+                <a:spcPts val="300"/>
+              </a:spcBef>
+            </a:pPr>
+            <a:r>
+              <a:rPr sz="1100" b="0">
+                <a:solidFill>
+                  <a:srgbClr val="334155"/>
+                </a:solidFill>
+                <a:latin typeface="Calibri"/>
+              </a:rPr>
+              <a:t>不是方案4的一部分：</a:t>
+            </a:r>
+          </a:p>
+          <a:p>
+            <a:pPr>
+              <a:spcBef>
+                <a:spcPts val="300"/>
+              </a:spcBef>
+            </a:pPr>
+            <a:r>
+              <a:rPr sz="1100" b="0">
+                <a:solidFill>
+                  <a:srgbClr val="334155"/>
+                </a:solidFill>
+                <a:latin typeface="Calibri"/>
+              </a:rPr>
+              <a:t/>
+            </a:r>
+          </a:p>
+          <a:p>
+            <a:pPr>
+              <a:spcBef>
+                <a:spcPts val="300"/>
+              </a:spcBef>
+            </a:pPr>
+            <a:r>
+              <a:rPr sz="1100" b="0">
+                <a:solidFill>
+                  <a:srgbClr val="334155"/>
+                </a:solidFill>
+                <a:latin typeface="Calibri"/>
+              </a:rPr>
+              <a:t>B：模型边生成，边把 HTML</a:t>
+            </a:r>
+          </a:p>
+          <a:p>
+            <a:pPr>
+              <a:spcBef>
+                <a:spcPts val="300"/>
+              </a:spcBef>
+            </a:pPr>
+            <a:r>
+              <a:rPr sz="1100" b="0">
+                <a:solidFill>
+                  <a:srgbClr val="334155"/>
+                </a:solidFill>
+                <a:latin typeface="Calibri"/>
+              </a:rPr>
+              <a:t>   片段推到端上刷新</a:t>
+            </a:r>
+          </a:p>
+          <a:p>
+            <a:pPr>
+              <a:spcBef>
+                <a:spcPts val="300"/>
+              </a:spcBef>
+            </a:pPr>
+            <a:r>
+              <a:rPr sz="1100" b="0">
+                <a:solidFill>
+                  <a:srgbClr val="334155"/>
+                </a:solidFill>
+                <a:latin typeface="Calibri"/>
+              </a:rPr>
+              <a:t/>
+            </a:r>
+          </a:p>
+          <a:p>
+            <a:pPr>
+              <a:spcBef>
+                <a:spcPts val="300"/>
+              </a:spcBef>
+            </a:pPr>
+            <a:r>
+              <a:rPr sz="1100" b="0">
+                <a:solidFill>
+                  <a:srgbClr val="334155"/>
+                </a:solidFill>
+                <a:latin typeface="Calibri"/>
+              </a:rPr>
+              <a:t>C：先流式粗看，完成后再</a:t>
+            </a:r>
+          </a:p>
+          <a:p>
+            <a:pPr>
+              <a:spcBef>
+                <a:spcPts val="300"/>
+              </a:spcBef>
+            </a:pPr>
+            <a:r>
+              <a:rPr sz="1100" b="0">
+                <a:solidFill>
+                  <a:srgbClr val="334155"/>
+                </a:solidFill>
+                <a:latin typeface="Calibri"/>
+              </a:rPr>
+              <a:t>   落盘/定稿替换</a:t>
+            </a:r>
+          </a:p>
+          <a:p>
+            <a:pPr>
+              <a:spcBef>
+                <a:spcPts val="300"/>
+              </a:spcBef>
+            </a:pPr>
+            <a:r>
+              <a:rPr sz="1100" b="0">
+                <a:solidFill>
+                  <a:srgbClr val="334155"/>
+                </a:solidFill>
+                <a:latin typeface="Calibri"/>
+              </a:rPr>
+              <a:t/>
+            </a:r>
+          </a:p>
+          <a:p>
+            <a:pPr>
+              <a:spcBef>
+                <a:spcPts val="300"/>
+              </a:spcBef>
+            </a:pPr>
+            <a:r>
+              <a:rPr sz="1100" b="0">
+                <a:solidFill>
+                  <a:srgbClr val="334155"/>
+                </a:solidFill>
+                <a:latin typeface="Calibri"/>
+              </a:rPr>
+              <a:t>你们定主路径=预览服务出链接后，</a:t>
+            </a:r>
+          </a:p>
+          <a:p>
+            <a:pPr>
+              <a:spcBef>
+                <a:spcPts val="300"/>
+              </a:spcBef>
+            </a:pPr>
+            <a:r>
+              <a:rPr sz="1100" b="0">
+                <a:solidFill>
+                  <a:srgbClr val="334155"/>
+                </a:solidFill>
+                <a:latin typeface="Calibri"/>
+              </a:rPr>
+              <a:t>B/C 可先不进架构图。</a:t>
+            </a:r>
+          </a:p>
+          <a:p>
+            <a:pPr>
+              <a:spcBef>
+                <a:spcPts val="300"/>
+              </a:spcBef>
+            </a:pPr>
+            <a:r>
+              <a:rPr sz="1100" b="0">
+                <a:solidFill>
+                  <a:srgbClr val="334155"/>
+                </a:solidFill>
+                <a:latin typeface="Calibri"/>
+              </a:rPr>
+              <a:t/>
+            </a:r>
+          </a:p>
+          <a:p>
+            <a:pPr>
+              <a:spcBef>
+                <a:spcPts val="300"/>
+              </a:spcBef>
+            </a:pPr>
+            <a:r>
+              <a:rPr sz="1100" b="0">
+                <a:solidFill>
+                  <a:srgbClr val="334155"/>
+                </a:solidFill>
+                <a:latin typeface="Calibri"/>
+              </a:rPr>
+              <a:t>本独立 PPT 已按此省略。</a:t>
             </a:r>
           </a:p>
         </p:txBody>

</xml_diff>

<commit_message>
docs: drop AK/SK from preview auth model in arch views
Co-authored-by: Lizzy67 <Lizzy67@users.noreply.github.com>
</commit_message>
<xml_diff>
--- a/docs/agent_html_arch_views.pptx
+++ b/docs/agent_html_arch_views.pptx
@@ -3729,7 +3729,7 @@
                 </a:solidFill>
                 <a:latin typeface="Calibri"/>
               </a:rPr>
-              <a:t>鉴权（待定）</a:t>
+              <a:t>鉴权</a:t>
             </a:r>
           </a:p>
           <a:p>
@@ -3745,7 +3745,7 @@
                 </a:solidFill>
                 <a:latin typeface="Calibri"/>
               </a:rPr>
-              <a:t>优先评估复用端云 AK/SK；WebView 打开链建议另议短签</a:t>
+              <a:t>不引入 AK/SK；publish 后签发短时可访问 preview_url</a:t>
             </a:r>
           </a:p>
         </p:txBody>
@@ -5296,7 +5296,7 @@
                 </a:solidFill>
                 <a:latin typeface="Calibri"/>
               </a:rPr>
-              <a:t>鉴权注记：Agent→预览服务 可复用端云 AK/SK；WebView 打开 URL 更适合短时签名/一次性 token（见说明页）</a:t>
+              <a:t>鉴权注记：不引入 AK/SK；预览服务签发短时 preview_url，WebView 仅打开该链接</a:t>
             </a:r>
           </a:p>
         </p:txBody>
@@ -6547,7 +6547,7 @@
                 </a:solidFill>
                 <a:latin typeface="Calibri"/>
               </a:rPr>
-              <a:t>青色=主路径　　灰色=备份路径（可与 5/6 并行，不阻塞预览）　　WebView 访问预览 URL 的鉴权方式见说明页待定项</a:t>
+              <a:t>青色=主路径　　灰色=备份路径（可与发布并行，不阻塞预览）　　WebView 仅打开短时 preview_url，不携带 AK/SK</a:t>
             </a:r>
           </a:p>
         </p:txBody>
@@ -6728,7 +6728,7 @@
                 </a:solidFill>
                 <a:latin typeface="Calibri"/>
               </a:rPr>
-              <a:t>说明：鉴权怎么选 · 单文件为何够用 · 流式 B/C 是什么</a:t>
+              <a:t>说明：鉴权口径 · 单文件为何够用 · 流式 B/C 是什么</a:t>
             </a:r>
           </a:p>
           <a:p>
@@ -6820,7 +6820,7 @@
                 </a:solidFill>
                 <a:latin typeface="Calibri"/>
               </a:rPr>
-              <a:t>鉴权建议（待你拍板）</a:t>
+              <a:t>鉴权口径（已定）</a:t>
             </a:r>
           </a:p>
           <a:p>
@@ -6836,7 +6836,7 @@
                 </a:solidFill>
                 <a:latin typeface="Calibri"/>
               </a:rPr>
-              <a:t>两条链路要分开看：</a:t>
+              <a:t>不引入 AK/SK。</a:t>
             </a:r>
           </a:p>
           <a:p>
@@ -6868,7 +6868,7 @@
                 </a:solidFill>
                 <a:latin typeface="Calibri"/>
               </a:rPr>
-              <a:t>A. Agent → 预览服务（服务间）</a:t>
+              <a:t>Agent 调用预览服务：</a:t>
             </a:r>
           </a:p>
           <a:p>
@@ -6884,7 +6884,7 @@
                 </a:solidFill>
                 <a:latin typeface="Calibri"/>
               </a:rPr>
-              <a:t>  可复用现有端云 AK/SK</a:t>
+              <a:t>  走现有服务间可信通道</a:t>
             </a:r>
           </a:p>
           <a:p>
@@ -6900,7 +6900,7 @@
                 </a:solidFill>
                 <a:latin typeface="Calibri"/>
               </a:rPr>
-              <a:t>  或内部服务凭证</a:t>
+              <a:t>  （内网 / 会话态等，不落 AKSK）</a:t>
             </a:r>
           </a:p>
           <a:p>
@@ -6932,7 +6932,7 @@
                 </a:solidFill>
                 <a:latin typeface="Calibri"/>
               </a:rPr>
-              <a:t>B. WebView → 打开 preview_url</a:t>
+              <a:t>端侧 WebView：</a:t>
             </a:r>
           </a:p>
           <a:p>
@@ -6948,7 +6948,7 @@
                 </a:solidFill>
                 <a:latin typeface="Calibri"/>
               </a:rPr>
-              <a:t>  不太适合直接塞 AK/SK</a:t>
+              <a:t>  只打开返回的 preview_url</a:t>
             </a:r>
           </a:p>
           <a:p>
@@ -6964,7 +6964,7 @@
                 </a:solidFill>
                 <a:latin typeface="Calibri"/>
               </a:rPr>
-              <a:t>  （密钥会进 WebView/日志）</a:t>
+              <a:t>  URL 自身短时有效即可</a:t>
             </a:r>
           </a:p>
           <a:p>
@@ -6996,7 +6996,7 @@
                 </a:solidFill>
                 <a:latin typeface="Calibri"/>
               </a:rPr>
-              <a:t>更常见：</a:t>
+              <a:t>原则：</a:t>
             </a:r>
           </a:p>
           <a:p>
@@ -7012,7 +7012,7 @@
                 </a:solidFill>
                 <a:latin typeface="Calibri"/>
               </a:rPr>
-              <a:t>  publish 时用 AK/SK 鉴权</a:t>
+              <a:t>  密钥不进 WebView</a:t>
             </a:r>
           </a:p>
           <a:p>
@@ -7028,23 +7028,7 @@
                 </a:solidFill>
                 <a:latin typeface="Calibri"/>
               </a:rPr>
-              <a:t>  返回短时签名 URL / 一次性 token</a:t>
-            </a:r>
-          </a:p>
-          <a:p>
-            <a:pPr>
-              <a:spcBef>
-                <a:spcPts val="300"/>
-              </a:spcBef>
-            </a:pPr>
-            <a:r>
-              <a:rPr sz="1100" b="0">
-                <a:solidFill>
-                  <a:srgbClr val="334155"/>
-                </a:solidFill>
-                <a:latin typeface="Calibri"/>
-              </a:rPr>
-              <a:t>  WebView 只拿这个链接打开</a:t>
+              <a:t>  不进 HTML，不进客户端本地</a:t>
             </a:r>
           </a:p>
         </p:txBody>

</xml_diff>